<commit_message>
doc updates, 16x16 lower half cv control
</commit_message>
<xml_diff>
--- a/releases/15_MLRws/docs/images/MLR_grid_ws.pptx
+++ b/releases/15_MLRws/docs/images/MLR_grid_ws.pptx
@@ -104,6 +104,11 @@
       </a:defRPr>
     </a:lvl9pPr>
   </p:defaultTextStyle>
+  <p:extLst>
+    <p:ext uri="{EFAFB233-063F-42B5-8137-9DF3F51BA10A}">
+      <p15:sldGuideLst xmlns:p15="http://schemas.microsoft.com/office/powerpoint/2012/main"/>
+    </p:ext>
+  </p:extLst>
 </p:presentation>
 </file>
 
@@ -254,7 +259,7 @@
           <a:p>
             <a:fld id="{4B93F2C2-4DCE-B34A-B9F0-2D739A90E669}" type="datetimeFigureOut">
               <a:rPr lang="en-US" smtClean="0"/>
-              <a:t>5/1/26</a:t>
+              <a:t>5/26/26</a:t>
             </a:fld>
             <a:endParaRPr lang="en-US"/>
           </a:p>
@@ -452,7 +457,7 @@
           <a:p>
             <a:fld id="{4B93F2C2-4DCE-B34A-B9F0-2D739A90E669}" type="datetimeFigureOut">
               <a:rPr lang="en-US" smtClean="0"/>
-              <a:t>5/1/26</a:t>
+              <a:t>5/26/26</a:t>
             </a:fld>
             <a:endParaRPr lang="en-US"/>
           </a:p>
@@ -660,7 +665,7 @@
           <a:p>
             <a:fld id="{4B93F2C2-4DCE-B34A-B9F0-2D739A90E669}" type="datetimeFigureOut">
               <a:rPr lang="en-US" smtClean="0"/>
-              <a:t>5/1/26</a:t>
+              <a:t>5/26/26</a:t>
             </a:fld>
             <a:endParaRPr lang="en-US"/>
           </a:p>
@@ -858,7 +863,7 @@
           <a:p>
             <a:fld id="{4B93F2C2-4DCE-B34A-B9F0-2D739A90E669}" type="datetimeFigureOut">
               <a:rPr lang="en-US" smtClean="0"/>
-              <a:t>5/1/26</a:t>
+              <a:t>5/26/26</a:t>
             </a:fld>
             <a:endParaRPr lang="en-US"/>
           </a:p>
@@ -1133,7 +1138,7 @@
           <a:p>
             <a:fld id="{4B93F2C2-4DCE-B34A-B9F0-2D739A90E669}" type="datetimeFigureOut">
               <a:rPr lang="en-US" smtClean="0"/>
-              <a:t>5/1/26</a:t>
+              <a:t>5/26/26</a:t>
             </a:fld>
             <a:endParaRPr lang="en-US"/>
           </a:p>
@@ -1398,7 +1403,7 @@
           <a:p>
             <a:fld id="{4B93F2C2-4DCE-B34A-B9F0-2D739A90E669}" type="datetimeFigureOut">
               <a:rPr lang="en-US" smtClean="0"/>
-              <a:t>5/1/26</a:t>
+              <a:t>5/26/26</a:t>
             </a:fld>
             <a:endParaRPr lang="en-US"/>
           </a:p>
@@ -1810,7 +1815,7 @@
           <a:p>
             <a:fld id="{4B93F2C2-4DCE-B34A-B9F0-2D739A90E669}" type="datetimeFigureOut">
               <a:rPr lang="en-US" smtClean="0"/>
-              <a:t>5/1/26</a:t>
+              <a:t>5/26/26</a:t>
             </a:fld>
             <a:endParaRPr lang="en-US"/>
           </a:p>
@@ -1951,7 +1956,7 @@
           <a:p>
             <a:fld id="{4B93F2C2-4DCE-B34A-B9F0-2D739A90E669}" type="datetimeFigureOut">
               <a:rPr lang="en-US" smtClean="0"/>
-              <a:t>5/1/26</a:t>
+              <a:t>5/26/26</a:t>
             </a:fld>
             <a:endParaRPr lang="en-US"/>
           </a:p>
@@ -2064,7 +2069,7 @@
           <a:p>
             <a:fld id="{4B93F2C2-4DCE-B34A-B9F0-2D739A90E669}" type="datetimeFigureOut">
               <a:rPr lang="en-US" smtClean="0"/>
-              <a:t>5/1/26</a:t>
+              <a:t>5/26/26</a:t>
             </a:fld>
             <a:endParaRPr lang="en-US"/>
           </a:p>
@@ -2375,7 +2380,7 @@
           <a:p>
             <a:fld id="{4B93F2C2-4DCE-B34A-B9F0-2D739A90E669}" type="datetimeFigureOut">
               <a:rPr lang="en-US" smtClean="0"/>
-              <a:t>5/1/26</a:t>
+              <a:t>5/26/26</a:t>
             </a:fld>
             <a:endParaRPr lang="en-US"/>
           </a:p>
@@ -2663,7 +2668,7 @@
           <a:p>
             <a:fld id="{4B93F2C2-4DCE-B34A-B9F0-2D739A90E669}" type="datetimeFigureOut">
               <a:rPr lang="en-US" smtClean="0"/>
-              <a:t>5/1/26</a:t>
+              <a:t>5/26/26</a:t>
             </a:fld>
             <a:endParaRPr lang="en-US"/>
           </a:p>
@@ -2904,7 +2909,7 @@
           <a:p>
             <a:fld id="{4B93F2C2-4DCE-B34A-B9F0-2D739A90E669}" type="datetimeFigureOut">
               <a:rPr lang="en-US" smtClean="0"/>
-              <a:t>5/1/26</a:t>
+              <a:t>5/26/26</a:t>
             </a:fld>
             <a:endParaRPr lang="en-US"/>
           </a:p>
@@ -3335,10 +3340,10 @@
         </p:nvGrpSpPr>
         <p:grpSpPr>
           <a:xfrm>
-            <a:off x="3669376" y="-420790"/>
-            <a:ext cx="3218262" cy="6802540"/>
-            <a:chOff x="7272285" y="-400173"/>
-            <a:chExt cx="3218262" cy="6802540"/>
+            <a:off x="4390087" y="55460"/>
+            <a:ext cx="2497551" cy="6802540"/>
+            <a:chOff x="7992996" y="-400173"/>
+            <a:chExt cx="2497551" cy="6802540"/>
           </a:xfrm>
         </p:grpSpPr>
         <p:pic>
@@ -3915,124 +3920,7 @@
                     </a:outerShdw>
                   </a:effectLst>
                 </a:rPr>
-                <a:t>Input L/mono</a:t>
-              </a:r>
-            </a:p>
-          </p:txBody>
-        </p:sp>
-        <p:sp>
-          <p:nvSpPr>
-            <p:cNvPr id="35" name="TextBox 34">
-              <a:extLst>
-                <a:ext uri="{FF2B5EF4-FFF2-40B4-BE49-F238E27FC236}">
-                  <a16:creationId xmlns:a16="http://schemas.microsoft.com/office/drawing/2014/main" id="{99CF5E3C-BB65-0CE7-2C0F-9FB38982268B}"/>
-                </a:ext>
-              </a:extLst>
-            </p:cNvPr>
-            <p:cNvSpPr txBox="1"/>
-            <p:nvPr/>
-          </p:nvSpPr>
-          <p:spPr>
-            <a:xfrm>
-              <a:off x="9117672" y="2848910"/>
-              <a:ext cx="582254" cy="215444"/>
-            </a:xfrm>
-            <a:prstGeom prst="rect">
-              <a:avLst/>
-            </a:prstGeom>
-            <a:noFill/>
-          </p:spPr>
-          <p:txBody>
-            <a:bodyPr wrap="square" rtlCol="0">
-              <a:spAutoFit/>
-            </a:bodyPr>
-            <a:lstStyle/>
-            <a:p>
-              <a:r>
-                <a:rPr lang="en-US" sz="800" b="1" dirty="0">
-                  <a:solidFill>
-                    <a:srgbClr val="00B0F0"/>
-                  </a:solidFill>
-                </a:rPr>
-                <a:t>CHAN 1</a:t>
-              </a:r>
-            </a:p>
-          </p:txBody>
-        </p:sp>
-        <p:sp>
-          <p:nvSpPr>
-            <p:cNvPr id="36" name="TextBox 35">
-              <a:extLst>
-                <a:ext uri="{FF2B5EF4-FFF2-40B4-BE49-F238E27FC236}">
-                  <a16:creationId xmlns:a16="http://schemas.microsoft.com/office/drawing/2014/main" id="{272527E8-D3E7-A720-55C3-B2C08D78AA5E}"/>
-                </a:ext>
-              </a:extLst>
-            </p:cNvPr>
-            <p:cNvSpPr txBox="1"/>
-            <p:nvPr/>
-          </p:nvSpPr>
-          <p:spPr>
-            <a:xfrm>
-              <a:off x="9535652" y="2859822"/>
-              <a:ext cx="582254" cy="215444"/>
-            </a:xfrm>
-            <a:prstGeom prst="rect">
-              <a:avLst/>
-            </a:prstGeom>
-            <a:noFill/>
-          </p:spPr>
-          <p:txBody>
-            <a:bodyPr wrap="square" rtlCol="0">
-              <a:spAutoFit/>
-            </a:bodyPr>
-            <a:lstStyle/>
-            <a:p>
-              <a:r>
-                <a:rPr lang="en-US" sz="800" b="1" dirty="0">
-                  <a:solidFill>
-                    <a:srgbClr val="7030A0"/>
-                  </a:solidFill>
-                </a:rPr>
-                <a:t>CHAN 2</a:t>
-              </a:r>
-            </a:p>
-          </p:txBody>
-        </p:sp>
-        <p:sp>
-          <p:nvSpPr>
-            <p:cNvPr id="37" name="TextBox 36">
-              <a:extLst>
-                <a:ext uri="{FF2B5EF4-FFF2-40B4-BE49-F238E27FC236}">
-                  <a16:creationId xmlns:a16="http://schemas.microsoft.com/office/drawing/2014/main" id="{30BB5CC7-F515-4505-598C-99FBEC57F8B7}"/>
-                </a:ext>
-              </a:extLst>
-            </p:cNvPr>
-            <p:cNvSpPr txBox="1"/>
-            <p:nvPr/>
-          </p:nvSpPr>
-          <p:spPr>
-            <a:xfrm>
-              <a:off x="7272285" y="2893482"/>
-              <a:ext cx="814790" cy="584775"/>
-            </a:xfrm>
-            <a:prstGeom prst="rect">
-              <a:avLst/>
-            </a:prstGeom>
-            <a:noFill/>
-          </p:spPr>
-          <p:txBody>
-            <a:bodyPr wrap="square" rtlCol="0">
-              <a:spAutoFit/>
-            </a:bodyPr>
-            <a:lstStyle/>
-            <a:p>
-              <a:r>
-                <a:rPr lang="en-US" sz="800" b="1" dirty="0">
-                  <a:solidFill>
-                    <a:srgbClr val="00B0F0"/>
-                  </a:solidFill>
-                </a:rPr>
-                <a:t>Mono or stereo based on UF2 installed</a:t>
+                <a:t>Input Chan 1</a:t>
               </a:r>
             </a:p>
           </p:txBody>
@@ -4052,7 +3940,7 @@
         </p:nvSpPr>
         <p:spPr>
           <a:xfrm>
-            <a:off x="5068455" y="3048598"/>
+            <a:off x="5068455" y="3524848"/>
             <a:ext cx="450547" cy="233310"/>
           </a:xfrm>
           <a:prstGeom prst="rect">
@@ -4100,7 +3988,7 @@
                   </a:outerShdw>
                 </a:effectLst>
               </a:rPr>
-              <a:t>Input R</a:t>
+              <a:t>Input Chan 2</a:t>
             </a:r>
           </a:p>
         </p:txBody>
@@ -4119,7 +4007,7 @@
         </p:nvSpPr>
         <p:spPr>
           <a:xfrm>
-            <a:off x="5537433" y="3048598"/>
+            <a:off x="5537433" y="3524848"/>
             <a:ext cx="450547" cy="233310"/>
           </a:xfrm>
           <a:prstGeom prst="rect">
@@ -4167,7 +4055,7 @@
                   </a:outerShdw>
                 </a:effectLst>
               </a:rPr>
-              <a:t>Output L/mono</a:t>
+              <a:t>Output Chan 1</a:t>
             </a:r>
           </a:p>
         </p:txBody>
@@ -4186,7 +4074,7 @@
         </p:nvSpPr>
         <p:spPr>
           <a:xfrm>
-            <a:off x="6018423" y="3040712"/>
+            <a:off x="6018423" y="3516962"/>
             <a:ext cx="450547" cy="233310"/>
           </a:xfrm>
           <a:prstGeom prst="rect">
@@ -4234,7 +4122,2488 @@
                   </a:outerShdw>
                 </a:effectLst>
               </a:rPr>
-              <a:t>Output R</a:t>
+              <a:t>Output Chan 2</a:t>
+            </a:r>
+          </a:p>
+        </p:txBody>
+      </p:sp>
+      <p:sp>
+        <p:nvSpPr>
+          <p:cNvPr id="2" name="Rectangle 1">
+            <a:extLst>
+              <a:ext uri="{FF2B5EF4-FFF2-40B4-BE49-F238E27FC236}">
+                <a16:creationId xmlns:a16="http://schemas.microsoft.com/office/drawing/2014/main" id="{CCD03703-9E07-61FD-E6A1-4256F9147949}"/>
+              </a:ext>
+            </a:extLst>
+          </p:cNvPr>
+          <p:cNvSpPr/>
+          <p:nvPr/>
+        </p:nvSpPr>
+        <p:spPr>
+          <a:xfrm>
+            <a:off x="5240548" y="2676491"/>
+            <a:ext cx="506552" cy="233310"/>
+          </a:xfrm>
+          <a:prstGeom prst="rect">
+            <a:avLst/>
+          </a:prstGeom>
+          <a:solidFill>
+            <a:srgbClr val="FFFF00"/>
+          </a:solidFill>
+          <a:ln>
+            <a:noFill/>
+          </a:ln>
+        </p:spPr>
+        <p:style>
+          <a:lnRef idx="2">
+            <a:schemeClr val="accent1">
+              <a:shade val="15000"/>
+            </a:schemeClr>
+          </a:lnRef>
+          <a:fillRef idx="1">
+            <a:schemeClr val="accent1"/>
+          </a:fillRef>
+          <a:effectRef idx="0">
+            <a:schemeClr val="accent1"/>
+          </a:effectRef>
+          <a:fontRef idx="minor">
+            <a:schemeClr val="lt1"/>
+          </a:fontRef>
+        </p:style>
+        <p:txBody>
+          <a:bodyPr rtlCol="0" anchor="ctr"/>
+          <a:lstStyle/>
+          <a:p>
+            <a:pPr algn="ctr"/>
+            <a:r>
+              <a:rPr lang="en-US" sz="600" dirty="0">
+                <a:ln w="0"/>
+                <a:solidFill>
+                  <a:schemeClr val="tx1"/>
+                </a:solidFill>
+                <a:effectLst>
+                  <a:outerShdw blurRad="38100" dist="19050" dir="2700000" algn="tl" rotWithShape="0">
+                    <a:schemeClr val="dk1">
+                      <a:alpha val="40000"/>
+                    </a:schemeClr>
+                  </a:outerShdw>
+                </a:effectLst>
+              </a:rPr>
+              <a:t>CV2 Env </a:t>
+            </a:r>
+            <a:r>
+              <a:rPr lang="en-US" sz="600" dirty="0" err="1">
+                <a:ln w="0"/>
+                <a:solidFill>
+                  <a:schemeClr val="tx1"/>
+                </a:solidFill>
+                <a:effectLst>
+                  <a:outerShdw blurRad="38100" dist="19050" dir="2700000" algn="tl" rotWithShape="0">
+                    <a:schemeClr val="dk1">
+                      <a:alpha val="40000"/>
+                    </a:schemeClr>
+                  </a:outerShdw>
+                </a:effectLst>
+              </a:rPr>
+              <a:t>Atk</a:t>
+            </a:r>
+            <a:r>
+              <a:rPr lang="en-US" sz="600" dirty="0">
+                <a:ln w="0"/>
+                <a:solidFill>
+                  <a:schemeClr val="tx1"/>
+                </a:solidFill>
+                <a:effectLst>
+                  <a:outerShdw blurRad="38100" dist="19050" dir="2700000" algn="tl" rotWithShape="0">
+                    <a:schemeClr val="dk1">
+                      <a:alpha val="40000"/>
+                    </a:schemeClr>
+                  </a:outerShdw>
+                </a:effectLst>
+              </a:rPr>
+              <a:t>/</a:t>
+            </a:r>
+            <a:r>
+              <a:rPr lang="en-US" sz="600" dirty="0" err="1">
+                <a:ln w="0"/>
+                <a:solidFill>
+                  <a:schemeClr val="tx1"/>
+                </a:solidFill>
+                <a:effectLst>
+                  <a:outerShdw blurRad="38100" dist="19050" dir="2700000" algn="tl" rotWithShape="0">
+                    <a:schemeClr val="dk1">
+                      <a:alpha val="40000"/>
+                    </a:schemeClr>
+                  </a:outerShdw>
+                </a:effectLst>
+              </a:rPr>
+              <a:t>Dcy</a:t>
+            </a:r>
+            <a:endParaRPr lang="en-US" sz="600" dirty="0">
+              <a:ln w="0"/>
+              <a:solidFill>
+                <a:schemeClr val="tx1"/>
+              </a:solidFill>
+              <a:effectLst>
+                <a:outerShdw blurRad="38100" dist="19050" dir="2700000" algn="tl" rotWithShape="0">
+                  <a:schemeClr val="dk1">
+                    <a:alpha val="40000"/>
+                  </a:schemeClr>
+                </a:outerShdw>
+              </a:effectLst>
+            </a:endParaRPr>
+          </a:p>
+        </p:txBody>
+      </p:sp>
+      <p:sp>
+        <p:nvSpPr>
+          <p:cNvPr id="3" name="Rectangle 2">
+            <a:extLst>
+              <a:ext uri="{FF2B5EF4-FFF2-40B4-BE49-F238E27FC236}">
+                <a16:creationId xmlns:a16="http://schemas.microsoft.com/office/drawing/2014/main" id="{F79682F6-81D2-34CE-4243-EA0C127415EB}"/>
+              </a:ext>
+            </a:extLst>
+          </p:cNvPr>
+          <p:cNvSpPr/>
+          <p:nvPr/>
+        </p:nvSpPr>
+        <p:spPr>
+          <a:xfrm>
+            <a:off x="5488271" y="4162182"/>
+            <a:ext cx="531240" cy="233310"/>
+          </a:xfrm>
+          <a:prstGeom prst="rect">
+            <a:avLst/>
+          </a:prstGeom>
+          <a:solidFill>
+            <a:srgbClr val="FFFF00"/>
+          </a:solidFill>
+          <a:ln>
+            <a:noFill/>
+          </a:ln>
+        </p:spPr>
+        <p:style>
+          <a:lnRef idx="2">
+            <a:schemeClr val="accent1">
+              <a:shade val="15000"/>
+            </a:schemeClr>
+          </a:lnRef>
+          <a:fillRef idx="1">
+            <a:schemeClr val="accent1"/>
+          </a:fillRef>
+          <a:effectRef idx="0">
+            <a:schemeClr val="accent1"/>
+          </a:effectRef>
+          <a:fontRef idx="minor">
+            <a:schemeClr val="lt1"/>
+          </a:fontRef>
+        </p:style>
+        <p:txBody>
+          <a:bodyPr rtlCol="0" anchor="ctr"/>
+          <a:lstStyle/>
+          <a:p>
+            <a:pPr algn="ctr"/>
+            <a:r>
+              <a:rPr lang="en-US" sz="600" dirty="0">
+                <a:ln w="0"/>
+                <a:solidFill>
+                  <a:schemeClr val="tx1"/>
+                </a:solidFill>
+                <a:effectLst>
+                  <a:outerShdw blurRad="38100" dist="19050" dir="2700000" algn="tl" rotWithShape="0">
+                    <a:schemeClr val="dk1">
+                      <a:alpha val="40000"/>
+                    </a:schemeClr>
+                  </a:outerShdw>
+                </a:effectLst>
+              </a:rPr>
+              <a:t>v/oct chromatic</a:t>
+            </a:r>
+          </a:p>
+        </p:txBody>
+      </p:sp>
+      <p:sp>
+        <p:nvSpPr>
+          <p:cNvPr id="9" name="Rectangle 8">
+            <a:extLst>
+              <a:ext uri="{FF2B5EF4-FFF2-40B4-BE49-F238E27FC236}">
+                <a16:creationId xmlns:a16="http://schemas.microsoft.com/office/drawing/2014/main" id="{411BAA3F-4DAF-2AF4-77EB-8A13815036CF}"/>
+              </a:ext>
+            </a:extLst>
+          </p:cNvPr>
+          <p:cNvSpPr/>
+          <p:nvPr/>
+        </p:nvSpPr>
+        <p:spPr>
+          <a:xfrm>
+            <a:off x="6040404" y="4162182"/>
+            <a:ext cx="385059" cy="233310"/>
+          </a:xfrm>
+          <a:prstGeom prst="rect">
+            <a:avLst/>
+          </a:prstGeom>
+          <a:solidFill>
+            <a:srgbClr val="FFFF00"/>
+          </a:solidFill>
+          <a:ln>
+            <a:noFill/>
+          </a:ln>
+        </p:spPr>
+        <p:style>
+          <a:lnRef idx="2">
+            <a:schemeClr val="accent1">
+              <a:shade val="15000"/>
+            </a:schemeClr>
+          </a:lnRef>
+          <a:fillRef idx="1">
+            <a:schemeClr val="accent1"/>
+          </a:fillRef>
+          <a:effectRef idx="0">
+            <a:schemeClr val="accent1"/>
+          </a:effectRef>
+          <a:fontRef idx="minor">
+            <a:schemeClr val="lt1"/>
+          </a:fontRef>
+        </p:style>
+        <p:txBody>
+          <a:bodyPr rtlCol="0" anchor="ctr"/>
+          <a:lstStyle/>
+          <a:p>
+            <a:pPr algn="ctr"/>
+            <a:r>
+              <a:rPr lang="en-US" sz="600" dirty="0">
+                <a:ln w="0"/>
+                <a:solidFill>
+                  <a:schemeClr val="tx1"/>
+                </a:solidFill>
+                <a:effectLst>
+                  <a:outerShdw blurRad="38100" dist="19050" dir="2700000" algn="tl" rotWithShape="0">
+                    <a:schemeClr val="dk1">
+                      <a:alpha val="40000"/>
+                    </a:schemeClr>
+                  </a:outerShdw>
+                </a:effectLst>
+              </a:rPr>
+              <a:t>AD Env</a:t>
+            </a:r>
+          </a:p>
+        </p:txBody>
+      </p:sp>
+      <p:sp>
+        <p:nvSpPr>
+          <p:cNvPr id="14" name="Rectangle 13">
+            <a:extLst>
+              <a:ext uri="{FF2B5EF4-FFF2-40B4-BE49-F238E27FC236}">
+                <a16:creationId xmlns:a16="http://schemas.microsoft.com/office/drawing/2014/main" id="{01F72349-B144-24FF-80F1-E69217F0E3C5}"/>
+              </a:ext>
+            </a:extLst>
+          </p:cNvPr>
+          <p:cNvSpPr/>
+          <p:nvPr/>
+        </p:nvSpPr>
+        <p:spPr>
+          <a:xfrm>
+            <a:off x="4584799" y="4813824"/>
+            <a:ext cx="444020" cy="233310"/>
+          </a:xfrm>
+          <a:prstGeom prst="rect">
+            <a:avLst/>
+          </a:prstGeom>
+          <a:solidFill>
+            <a:srgbClr val="FFFF00"/>
+          </a:solidFill>
+          <a:ln>
+            <a:noFill/>
+          </a:ln>
+        </p:spPr>
+        <p:style>
+          <a:lnRef idx="2">
+            <a:schemeClr val="accent1">
+              <a:shade val="15000"/>
+            </a:schemeClr>
+          </a:lnRef>
+          <a:fillRef idx="1">
+            <a:schemeClr val="accent1"/>
+          </a:fillRef>
+          <a:effectRef idx="0">
+            <a:schemeClr val="accent1"/>
+          </a:effectRef>
+          <a:fontRef idx="minor">
+            <a:schemeClr val="lt1"/>
+          </a:fontRef>
+        </p:style>
+        <p:txBody>
+          <a:bodyPr rtlCol="0" anchor="ctr"/>
+          <a:lstStyle/>
+          <a:p>
+            <a:pPr algn="ctr"/>
+            <a:r>
+              <a:rPr lang="en-US" sz="600" dirty="0">
+                <a:ln w="0"/>
+                <a:solidFill>
+                  <a:schemeClr val="tx1"/>
+                </a:solidFill>
+                <a:effectLst>
+                  <a:outerShdw blurRad="38100" dist="19050" dir="2700000" algn="tl" rotWithShape="0">
+                    <a:schemeClr val="dk1">
+                      <a:alpha val="40000"/>
+                    </a:schemeClr>
+                  </a:outerShdw>
+                </a:effectLst>
+              </a:rPr>
+              <a:t>Reset loops</a:t>
+            </a:r>
+          </a:p>
+        </p:txBody>
+      </p:sp>
+      <p:sp>
+        <p:nvSpPr>
+          <p:cNvPr id="16" name="Rectangle 15">
+            <a:extLst>
+              <a:ext uri="{FF2B5EF4-FFF2-40B4-BE49-F238E27FC236}">
+                <a16:creationId xmlns:a16="http://schemas.microsoft.com/office/drawing/2014/main" id="{893E01CB-14C0-DBE3-AC23-3C3641ACBF3E}"/>
+              </a:ext>
+            </a:extLst>
+          </p:cNvPr>
+          <p:cNvSpPr/>
+          <p:nvPr/>
+        </p:nvSpPr>
+        <p:spPr>
+          <a:xfrm>
+            <a:off x="5060155" y="4810784"/>
+            <a:ext cx="444019" cy="233310"/>
+          </a:xfrm>
+          <a:prstGeom prst="rect">
+            <a:avLst/>
+          </a:prstGeom>
+          <a:solidFill>
+            <a:srgbClr val="FFFF00"/>
+          </a:solidFill>
+          <a:ln>
+            <a:noFill/>
+          </a:ln>
+        </p:spPr>
+        <p:style>
+          <a:lnRef idx="2">
+            <a:schemeClr val="accent1">
+              <a:shade val="15000"/>
+            </a:schemeClr>
+          </a:lnRef>
+          <a:fillRef idx="1">
+            <a:schemeClr val="accent1"/>
+          </a:fillRef>
+          <a:effectRef idx="0">
+            <a:schemeClr val="accent1"/>
+          </a:effectRef>
+          <a:fontRef idx="minor">
+            <a:schemeClr val="lt1"/>
+          </a:fontRef>
+        </p:style>
+        <p:txBody>
+          <a:bodyPr rtlCol="0" anchor="ctr"/>
+          <a:lstStyle/>
+          <a:p>
+            <a:pPr algn="ctr"/>
+            <a:r>
+              <a:rPr lang="en-US" sz="600" dirty="0">
+                <a:ln w="0"/>
+                <a:solidFill>
+                  <a:schemeClr val="tx1"/>
+                </a:solidFill>
+                <a:effectLst>
+                  <a:outerShdw blurRad="38100" dist="19050" dir="2700000" algn="tl" rotWithShape="0">
+                    <a:schemeClr val="dk1">
+                      <a:alpha val="40000"/>
+                    </a:schemeClr>
+                  </a:outerShdw>
+                </a:effectLst>
+              </a:rPr>
+              <a:t>Gated record</a:t>
+            </a:r>
+          </a:p>
+        </p:txBody>
+      </p:sp>
+      <p:sp>
+        <p:nvSpPr>
+          <p:cNvPr id="17" name="Rectangle 16">
+            <a:extLst>
+              <a:ext uri="{FF2B5EF4-FFF2-40B4-BE49-F238E27FC236}">
+                <a16:creationId xmlns:a16="http://schemas.microsoft.com/office/drawing/2014/main" id="{21001677-693B-DF4D-D4E9-0398B460037F}"/>
+              </a:ext>
+            </a:extLst>
+          </p:cNvPr>
+          <p:cNvSpPr/>
+          <p:nvPr/>
+        </p:nvSpPr>
+        <p:spPr>
+          <a:xfrm>
+            <a:off x="5529877" y="4813824"/>
+            <a:ext cx="444019" cy="233310"/>
+          </a:xfrm>
+          <a:prstGeom prst="rect">
+            <a:avLst/>
+          </a:prstGeom>
+          <a:solidFill>
+            <a:srgbClr val="FFFF00"/>
+          </a:solidFill>
+          <a:ln>
+            <a:noFill/>
+          </a:ln>
+        </p:spPr>
+        <p:style>
+          <a:lnRef idx="2">
+            <a:schemeClr val="accent1">
+              <a:shade val="15000"/>
+            </a:schemeClr>
+          </a:lnRef>
+          <a:fillRef idx="1">
+            <a:schemeClr val="accent1"/>
+          </a:fillRef>
+          <a:effectRef idx="0">
+            <a:schemeClr val="accent1"/>
+          </a:effectRef>
+          <a:fontRef idx="minor">
+            <a:schemeClr val="lt1"/>
+          </a:fontRef>
+        </p:style>
+        <p:txBody>
+          <a:bodyPr rtlCol="0" anchor="ctr"/>
+          <a:lstStyle/>
+          <a:p>
+            <a:pPr algn="ctr"/>
+            <a:r>
+              <a:rPr lang="en-US" sz="600" dirty="0">
+                <a:ln w="0"/>
+                <a:solidFill>
+                  <a:schemeClr val="tx1"/>
+                </a:solidFill>
+                <a:effectLst>
+                  <a:outerShdw blurRad="38100" dist="19050" dir="2700000" algn="tl" rotWithShape="0">
+                    <a:schemeClr val="dk1">
+                      <a:alpha val="40000"/>
+                    </a:schemeClr>
+                  </a:outerShdw>
+                </a:effectLst>
+              </a:rPr>
+              <a:t>CUT triggers</a:t>
+            </a:r>
+          </a:p>
+        </p:txBody>
+      </p:sp>
+      <p:sp>
+        <p:nvSpPr>
+          <p:cNvPr id="18" name="Rectangle 17">
+            <a:extLst>
+              <a:ext uri="{FF2B5EF4-FFF2-40B4-BE49-F238E27FC236}">
+                <a16:creationId xmlns:a16="http://schemas.microsoft.com/office/drawing/2014/main" id="{B50DABC7-50A4-9AA7-2BA5-F8FAD5D58FAA}"/>
+              </a:ext>
+            </a:extLst>
+          </p:cNvPr>
+          <p:cNvSpPr/>
+          <p:nvPr/>
+        </p:nvSpPr>
+        <p:spPr>
+          <a:xfrm>
+            <a:off x="5999613" y="4813824"/>
+            <a:ext cx="444019" cy="233310"/>
+          </a:xfrm>
+          <a:prstGeom prst="rect">
+            <a:avLst/>
+          </a:prstGeom>
+          <a:solidFill>
+            <a:srgbClr val="FFFF00"/>
+          </a:solidFill>
+          <a:ln>
+            <a:noFill/>
+          </a:ln>
+        </p:spPr>
+        <p:style>
+          <a:lnRef idx="2">
+            <a:schemeClr val="accent1">
+              <a:shade val="15000"/>
+            </a:schemeClr>
+          </a:lnRef>
+          <a:fillRef idx="1">
+            <a:schemeClr val="accent1"/>
+          </a:fillRef>
+          <a:effectRef idx="0">
+            <a:schemeClr val="accent1"/>
+          </a:effectRef>
+          <a:fontRef idx="minor">
+            <a:schemeClr val="lt1"/>
+          </a:fontRef>
+        </p:style>
+        <p:txBody>
+          <a:bodyPr rtlCol="0" anchor="ctr"/>
+          <a:lstStyle/>
+          <a:p>
+            <a:pPr algn="ctr"/>
+            <a:r>
+              <a:rPr lang="en-US" sz="600" dirty="0">
+                <a:ln w="0"/>
+                <a:solidFill>
+                  <a:schemeClr val="tx1"/>
+                </a:solidFill>
+                <a:effectLst>
+                  <a:outerShdw blurRad="38100" dist="19050" dir="2700000" algn="tl" rotWithShape="0">
+                    <a:schemeClr val="dk1">
+                      <a:alpha val="40000"/>
+                    </a:schemeClr>
+                  </a:outerShdw>
+                </a:effectLst>
+              </a:rPr>
+              <a:t>CUT gates</a:t>
+            </a:r>
+          </a:p>
+        </p:txBody>
+      </p:sp>
+      <p:grpSp>
+        <p:nvGrpSpPr>
+          <p:cNvPr id="19" name="Group 18">
+            <a:extLst>
+              <a:ext uri="{FF2B5EF4-FFF2-40B4-BE49-F238E27FC236}">
+                <a16:creationId xmlns:a16="http://schemas.microsoft.com/office/drawing/2014/main" id="{57089A40-4D40-FEEE-2FDC-DA50D38B14D3}"/>
+              </a:ext>
+            </a:extLst>
+          </p:cNvPr>
+          <p:cNvGrpSpPr/>
+          <p:nvPr/>
+        </p:nvGrpSpPr>
+        <p:grpSpPr>
+          <a:xfrm>
+            <a:off x="8517960" y="-117260"/>
+            <a:ext cx="2497551" cy="6802540"/>
+            <a:chOff x="7992996" y="-400173"/>
+            <a:chExt cx="2497551" cy="6802540"/>
+          </a:xfrm>
+        </p:grpSpPr>
+        <p:pic>
+          <p:nvPicPr>
+            <p:cNvPr id="20" name="Picture 19">
+              <a:extLst>
+                <a:ext uri="{FF2B5EF4-FFF2-40B4-BE49-F238E27FC236}">
+                  <a16:creationId xmlns:a16="http://schemas.microsoft.com/office/drawing/2014/main" id="{96F659B2-2A1D-55CA-92F5-4C445787AC6A}"/>
+                </a:ext>
+              </a:extLst>
+            </p:cNvPr>
+            <p:cNvPicPr>
+              <a:picLocks noChangeAspect="1"/>
+            </p:cNvPicPr>
+            <p:nvPr/>
+          </p:nvPicPr>
+          <p:blipFill>
+            <a:blip r:embed="rId2"/>
+            <a:stretch>
+              <a:fillRect/>
+            </a:stretch>
+          </p:blipFill>
+          <p:spPr>
+            <a:xfrm>
+              <a:off x="7992996" y="-400173"/>
+              <a:ext cx="2497551" cy="6802540"/>
+            </a:xfrm>
+            <a:prstGeom prst="rect">
+              <a:avLst/>
+            </a:prstGeom>
+          </p:spPr>
+        </p:pic>
+        <p:sp>
+          <p:nvSpPr>
+            <p:cNvPr id="21" name="Rectangle 20">
+              <a:extLst>
+                <a:ext uri="{FF2B5EF4-FFF2-40B4-BE49-F238E27FC236}">
+                  <a16:creationId xmlns:a16="http://schemas.microsoft.com/office/drawing/2014/main" id="{311DEEA5-5261-6445-1D62-7F29AC1EEE15}"/>
+                </a:ext>
+              </a:extLst>
+            </p:cNvPr>
+            <p:cNvSpPr/>
+            <p:nvPr/>
+          </p:nvSpPr>
+          <p:spPr>
+            <a:xfrm>
+              <a:off x="8642432" y="1194278"/>
+              <a:ext cx="995819" cy="548887"/>
+            </a:xfrm>
+            <a:prstGeom prst="rect">
+              <a:avLst/>
+            </a:prstGeom>
+            <a:solidFill>
+              <a:srgbClr val="FFFF00"/>
+            </a:solidFill>
+            <a:ln>
+              <a:noFill/>
+            </a:ln>
+          </p:spPr>
+          <p:style>
+            <a:lnRef idx="2">
+              <a:schemeClr val="accent1">
+                <a:shade val="15000"/>
+              </a:schemeClr>
+            </a:lnRef>
+            <a:fillRef idx="1">
+              <a:schemeClr val="accent1"/>
+            </a:fillRef>
+            <a:effectRef idx="0">
+              <a:schemeClr val="accent1"/>
+            </a:effectRef>
+            <a:fontRef idx="minor">
+              <a:schemeClr val="lt1"/>
+            </a:fontRef>
+          </p:style>
+          <p:txBody>
+            <a:bodyPr rtlCol="0" anchor="ctr"/>
+            <a:lstStyle/>
+            <a:p>
+              <a:pPr algn="ctr"/>
+              <a:r>
+                <a:rPr lang="en-US" dirty="0">
+                  <a:ln w="0"/>
+                  <a:solidFill>
+                    <a:schemeClr val="tx1"/>
+                  </a:solidFill>
+                  <a:effectLst>
+                    <a:outerShdw blurRad="38100" dist="19050" dir="2700000" algn="tl" rotWithShape="0">
+                      <a:schemeClr val="dk1">
+                        <a:alpha val="40000"/>
+                      </a:schemeClr>
+                    </a:outerShdw>
+                  </a:effectLst>
+                </a:rPr>
+                <a:t>Active Track</a:t>
+              </a:r>
+            </a:p>
+          </p:txBody>
+        </p:sp>
+        <p:sp>
+          <p:nvSpPr>
+            <p:cNvPr id="24" name="Rectangle 23">
+              <a:extLst>
+                <a:ext uri="{FF2B5EF4-FFF2-40B4-BE49-F238E27FC236}">
+                  <a16:creationId xmlns:a16="http://schemas.microsoft.com/office/drawing/2014/main" id="{45729C3C-8A3B-EDCB-963B-9800196263FC}"/>
+                </a:ext>
+              </a:extLst>
+            </p:cNvPr>
+            <p:cNvSpPr/>
+            <p:nvPr/>
+          </p:nvSpPr>
+          <p:spPr>
+            <a:xfrm>
+              <a:off x="9436058" y="2093078"/>
+              <a:ext cx="592317" cy="233310"/>
+            </a:xfrm>
+            <a:prstGeom prst="rect">
+              <a:avLst/>
+            </a:prstGeom>
+            <a:solidFill>
+              <a:schemeClr val="accent4"/>
+            </a:solidFill>
+            <a:ln>
+              <a:noFill/>
+            </a:ln>
+          </p:spPr>
+          <p:style>
+            <a:lnRef idx="2">
+              <a:schemeClr val="accent1">
+                <a:shade val="15000"/>
+              </a:schemeClr>
+            </a:lnRef>
+            <a:fillRef idx="1">
+              <a:schemeClr val="accent1"/>
+            </a:fillRef>
+            <a:effectRef idx="0">
+              <a:schemeClr val="accent1"/>
+            </a:effectRef>
+            <a:fontRef idx="minor">
+              <a:schemeClr val="lt1"/>
+            </a:fontRef>
+          </p:style>
+          <p:txBody>
+            <a:bodyPr rtlCol="0" anchor="ctr"/>
+            <a:lstStyle/>
+            <a:p>
+              <a:pPr algn="ctr"/>
+              <a:r>
+                <a:rPr lang="en-US" sz="600" dirty="0">
+                  <a:ln w="0"/>
+                  <a:solidFill>
+                    <a:schemeClr val="bg1"/>
+                  </a:solidFill>
+                  <a:effectLst>
+                    <a:outerShdw blurRad="38100" dist="19050" dir="2700000" algn="tl" rotWithShape="0">
+                      <a:schemeClr val="dk1">
+                        <a:alpha val="40000"/>
+                      </a:schemeClr>
+                    </a:outerShdw>
+                  </a:effectLst>
+                </a:rPr>
+                <a:t>TRACK mode</a:t>
+              </a:r>
+            </a:p>
+          </p:txBody>
+        </p:sp>
+        <p:sp>
+          <p:nvSpPr>
+            <p:cNvPr id="25" name="Rectangle 24">
+              <a:extLst>
+                <a:ext uri="{FF2B5EF4-FFF2-40B4-BE49-F238E27FC236}">
+                  <a16:creationId xmlns:a16="http://schemas.microsoft.com/office/drawing/2014/main" id="{80791B73-31A0-AD93-9CAA-1A0CB969668B}"/>
+                </a:ext>
+              </a:extLst>
+            </p:cNvPr>
+            <p:cNvSpPr/>
+            <p:nvPr/>
+          </p:nvSpPr>
+          <p:spPr>
+            <a:xfrm>
+              <a:off x="9387759" y="2352068"/>
+              <a:ext cx="640615" cy="154525"/>
+            </a:xfrm>
+            <a:prstGeom prst="rect">
+              <a:avLst/>
+            </a:prstGeom>
+            <a:solidFill>
+              <a:srgbClr val="FFFF00"/>
+            </a:solidFill>
+            <a:ln>
+              <a:noFill/>
+            </a:ln>
+          </p:spPr>
+          <p:style>
+            <a:lnRef idx="2">
+              <a:schemeClr val="accent1">
+                <a:shade val="15000"/>
+              </a:schemeClr>
+            </a:lnRef>
+            <a:fillRef idx="1">
+              <a:schemeClr val="accent1"/>
+            </a:fillRef>
+            <a:effectRef idx="0">
+              <a:schemeClr val="accent1"/>
+            </a:effectRef>
+            <a:fontRef idx="minor">
+              <a:schemeClr val="lt1"/>
+            </a:fontRef>
+          </p:style>
+          <p:txBody>
+            <a:bodyPr rtlCol="0" anchor="ctr"/>
+            <a:lstStyle/>
+            <a:p>
+              <a:pPr algn="ctr"/>
+              <a:r>
+                <a:rPr lang="en-US" sz="600" dirty="0">
+                  <a:ln w="0"/>
+                  <a:solidFill>
+                    <a:schemeClr val="tx1"/>
+                  </a:solidFill>
+                  <a:effectLst>
+                    <a:outerShdw blurRad="38100" dist="19050" dir="2700000" algn="tl" rotWithShape="0">
+                      <a:schemeClr val="dk1">
+                        <a:alpha val="40000"/>
+                      </a:schemeClr>
+                    </a:outerShdw>
+                  </a:effectLst>
+                </a:rPr>
+                <a:t>GLOBAL mode</a:t>
+              </a:r>
+            </a:p>
+          </p:txBody>
+        </p:sp>
+        <p:sp>
+          <p:nvSpPr>
+            <p:cNvPr id="26" name="Rectangle 25">
+              <a:extLst>
+                <a:ext uri="{FF2B5EF4-FFF2-40B4-BE49-F238E27FC236}">
+                  <a16:creationId xmlns:a16="http://schemas.microsoft.com/office/drawing/2014/main" id="{028CDF28-AEDD-F3E5-BF11-14D23F3CECFB}"/>
+                </a:ext>
+              </a:extLst>
+            </p:cNvPr>
+            <p:cNvSpPr/>
+            <p:nvPr/>
+          </p:nvSpPr>
+          <p:spPr>
+            <a:xfrm>
+              <a:off x="9436055" y="2511829"/>
+              <a:ext cx="592317" cy="273134"/>
+            </a:xfrm>
+            <a:prstGeom prst="rect">
+              <a:avLst/>
+            </a:prstGeom>
+            <a:solidFill>
+              <a:srgbClr val="FFFF00"/>
+            </a:solidFill>
+            <a:ln>
+              <a:noFill/>
+            </a:ln>
+          </p:spPr>
+          <p:style>
+            <a:lnRef idx="2">
+              <a:schemeClr val="accent1">
+                <a:shade val="15000"/>
+              </a:schemeClr>
+            </a:lnRef>
+            <a:fillRef idx="1">
+              <a:schemeClr val="accent1"/>
+            </a:fillRef>
+            <a:effectRef idx="0">
+              <a:schemeClr val="accent1"/>
+            </a:effectRef>
+            <a:fontRef idx="minor">
+              <a:schemeClr val="lt1"/>
+            </a:fontRef>
+          </p:style>
+          <p:txBody>
+            <a:bodyPr rtlCol="0" anchor="ctr"/>
+            <a:lstStyle/>
+            <a:p>
+              <a:pPr algn="ctr"/>
+              <a:r>
+                <a:rPr lang="en-US" sz="600" dirty="0">
+                  <a:ln w="0"/>
+                  <a:solidFill>
+                    <a:schemeClr val="tx1"/>
+                  </a:solidFill>
+                  <a:effectLst>
+                    <a:outerShdw blurRad="38100" dist="19050" dir="2700000" algn="tl" rotWithShape="0">
+                      <a:schemeClr val="dk1">
+                        <a:alpha val="40000"/>
+                      </a:schemeClr>
+                    </a:outerShdw>
+                  </a:effectLst>
+                </a:rPr>
+                <a:t>Reset active track</a:t>
+              </a:r>
+              <a:endParaRPr lang="en-US" sz="700" dirty="0">
+                <a:ln w="0"/>
+                <a:solidFill>
+                  <a:schemeClr val="tx1"/>
+                </a:solidFill>
+                <a:effectLst>
+                  <a:outerShdw blurRad="38100" dist="19050" dir="2700000" algn="tl" rotWithShape="0">
+                    <a:schemeClr val="dk1">
+                      <a:alpha val="40000"/>
+                    </a:schemeClr>
+                  </a:outerShdw>
+                </a:effectLst>
+              </a:endParaRPr>
+            </a:p>
+          </p:txBody>
+        </p:sp>
+        <p:sp>
+          <p:nvSpPr>
+            <p:cNvPr id="27" name="Rectangle 26">
+              <a:extLst>
+                <a:ext uri="{FF2B5EF4-FFF2-40B4-BE49-F238E27FC236}">
+                  <a16:creationId xmlns:a16="http://schemas.microsoft.com/office/drawing/2014/main" id="{801247C7-5021-F383-621C-43A9A233A7A6}"/>
+                </a:ext>
+              </a:extLst>
+            </p:cNvPr>
+            <p:cNvSpPr/>
+            <p:nvPr/>
+          </p:nvSpPr>
+          <p:spPr>
+            <a:xfrm>
+              <a:off x="8247015" y="2234264"/>
+              <a:ext cx="506552" cy="293272"/>
+            </a:xfrm>
+            <a:prstGeom prst="rect">
+              <a:avLst/>
+            </a:prstGeom>
+            <a:solidFill>
+              <a:srgbClr val="FFFF00"/>
+            </a:solidFill>
+            <a:ln>
+              <a:noFill/>
+            </a:ln>
+          </p:spPr>
+          <p:style>
+            <a:lnRef idx="2">
+              <a:schemeClr val="accent1">
+                <a:shade val="15000"/>
+              </a:schemeClr>
+            </a:lnRef>
+            <a:fillRef idx="1">
+              <a:schemeClr val="accent1"/>
+            </a:fillRef>
+            <a:effectRef idx="0">
+              <a:schemeClr val="accent1"/>
+            </a:effectRef>
+            <a:fontRef idx="minor">
+              <a:schemeClr val="lt1"/>
+            </a:fontRef>
+          </p:style>
+          <p:txBody>
+            <a:bodyPr rtlCol="0" anchor="ctr"/>
+            <a:lstStyle/>
+            <a:p>
+              <a:pPr algn="ctr"/>
+              <a:r>
+                <a:rPr lang="en-US" sz="600" dirty="0">
+                  <a:ln w="0"/>
+                  <a:solidFill>
+                    <a:schemeClr val="tx1"/>
+                  </a:solidFill>
+                  <a:effectLst>
+                    <a:outerShdw blurRad="38100" dist="19050" dir="2700000" algn="tl" rotWithShape="0">
+                      <a:schemeClr val="dk1">
+                        <a:alpha val="40000"/>
+                      </a:schemeClr>
+                    </a:outerShdw>
+                  </a:effectLst>
+                </a:rPr>
+                <a:t>Active track level</a:t>
+              </a:r>
+            </a:p>
+          </p:txBody>
+        </p:sp>
+        <p:sp>
+          <p:nvSpPr>
+            <p:cNvPr id="28" name="Rectangle 27">
+              <a:extLst>
+                <a:ext uri="{FF2B5EF4-FFF2-40B4-BE49-F238E27FC236}">
+                  <a16:creationId xmlns:a16="http://schemas.microsoft.com/office/drawing/2014/main" id="{32CD6BCD-E493-8519-16DC-BDA3EF48D713}"/>
+                </a:ext>
+              </a:extLst>
+            </p:cNvPr>
+            <p:cNvSpPr/>
+            <p:nvPr/>
+          </p:nvSpPr>
+          <p:spPr>
+            <a:xfrm>
+              <a:off x="8042676" y="2987132"/>
+              <a:ext cx="592316" cy="233310"/>
+            </a:xfrm>
+            <a:prstGeom prst="rect">
+              <a:avLst/>
+            </a:prstGeom>
+            <a:solidFill>
+              <a:srgbClr val="FFFF00"/>
+            </a:solidFill>
+            <a:ln>
+              <a:noFill/>
+            </a:ln>
+          </p:spPr>
+          <p:style>
+            <a:lnRef idx="2">
+              <a:schemeClr val="accent1">
+                <a:shade val="15000"/>
+              </a:schemeClr>
+            </a:lnRef>
+            <a:fillRef idx="1">
+              <a:schemeClr val="accent1"/>
+            </a:fillRef>
+            <a:effectRef idx="0">
+              <a:schemeClr val="accent1"/>
+            </a:effectRef>
+            <a:fontRef idx="minor">
+              <a:schemeClr val="lt1"/>
+            </a:fontRef>
+          </p:style>
+          <p:txBody>
+            <a:bodyPr rtlCol="0" anchor="ctr"/>
+            <a:lstStyle/>
+            <a:p>
+              <a:pPr algn="ctr"/>
+              <a:r>
+                <a:rPr lang="en-US" sz="600" dirty="0">
+                  <a:ln w="0"/>
+                  <a:solidFill>
+                    <a:schemeClr val="tx1"/>
+                  </a:solidFill>
+                  <a:effectLst>
+                    <a:outerShdw blurRad="38100" dist="19050" dir="2700000" algn="tl" rotWithShape="0">
+                      <a:schemeClr val="dk1">
+                        <a:alpha val="40000"/>
+                      </a:schemeClr>
+                    </a:outerShdw>
+                  </a:effectLst>
+                </a:rPr>
+                <a:t>Mod active Track</a:t>
+              </a:r>
+            </a:p>
+          </p:txBody>
+        </p:sp>
+      </p:grpSp>
+      <p:sp>
+        <p:nvSpPr>
+          <p:cNvPr id="29" name="Rectangle 28">
+            <a:extLst>
+              <a:ext uri="{FF2B5EF4-FFF2-40B4-BE49-F238E27FC236}">
+                <a16:creationId xmlns:a16="http://schemas.microsoft.com/office/drawing/2014/main" id="{24DFC325-BCCD-C058-490F-8969F22BEBAF}"/>
+              </a:ext>
+            </a:extLst>
+          </p:cNvPr>
+          <p:cNvSpPr/>
+          <p:nvPr/>
+        </p:nvSpPr>
+        <p:spPr>
+          <a:xfrm>
+            <a:off x="9193063" y="3270045"/>
+            <a:ext cx="450547" cy="233310"/>
+          </a:xfrm>
+          <a:prstGeom prst="rect">
+            <a:avLst/>
+          </a:prstGeom>
+          <a:solidFill>
+            <a:srgbClr val="FFFF00"/>
+          </a:solidFill>
+          <a:ln>
+            <a:noFill/>
+          </a:ln>
+        </p:spPr>
+        <p:style>
+          <a:lnRef idx="2">
+            <a:schemeClr val="accent1">
+              <a:shade val="15000"/>
+            </a:schemeClr>
+          </a:lnRef>
+          <a:fillRef idx="1">
+            <a:schemeClr val="accent1"/>
+          </a:fillRef>
+          <a:effectRef idx="0">
+            <a:schemeClr val="accent1"/>
+          </a:effectRef>
+          <a:fontRef idx="minor">
+            <a:schemeClr val="lt1"/>
+          </a:fontRef>
+        </p:style>
+        <p:txBody>
+          <a:bodyPr rtlCol="0" anchor="ctr"/>
+          <a:lstStyle/>
+          <a:p>
+            <a:pPr algn="ctr"/>
+            <a:r>
+              <a:rPr lang="en-US" sz="600" dirty="0">
+                <a:ln w="0"/>
+                <a:solidFill>
+                  <a:schemeClr val="tx1"/>
+                </a:solidFill>
+                <a:effectLst>
+                  <a:outerShdw blurRad="38100" dist="19050" dir="2700000" algn="tl" rotWithShape="0">
+                    <a:schemeClr val="dk1">
+                      <a:alpha val="40000"/>
+                    </a:schemeClr>
+                  </a:outerShdw>
+                </a:effectLst>
+              </a:rPr>
+              <a:t>Mod active speed</a:t>
+            </a:r>
+          </a:p>
+        </p:txBody>
+      </p:sp>
+      <p:sp>
+        <p:nvSpPr>
+          <p:cNvPr id="30" name="Rectangle 29">
+            <a:extLst>
+              <a:ext uri="{FF2B5EF4-FFF2-40B4-BE49-F238E27FC236}">
+                <a16:creationId xmlns:a16="http://schemas.microsoft.com/office/drawing/2014/main" id="{096725C4-9DCB-1FB6-B8BA-517500F83994}"/>
+              </a:ext>
+            </a:extLst>
+          </p:cNvPr>
+          <p:cNvSpPr/>
+          <p:nvPr/>
+        </p:nvSpPr>
+        <p:spPr>
+          <a:xfrm>
+            <a:off x="9665306" y="3352128"/>
+            <a:ext cx="450547" cy="233310"/>
+          </a:xfrm>
+          <a:prstGeom prst="rect">
+            <a:avLst/>
+          </a:prstGeom>
+          <a:solidFill>
+            <a:srgbClr val="FFFF00"/>
+          </a:solidFill>
+          <a:ln>
+            <a:noFill/>
+          </a:ln>
+        </p:spPr>
+        <p:style>
+          <a:lnRef idx="2">
+            <a:schemeClr val="accent1">
+              <a:shade val="15000"/>
+            </a:schemeClr>
+          </a:lnRef>
+          <a:fillRef idx="1">
+            <a:schemeClr val="accent1"/>
+          </a:fillRef>
+          <a:effectRef idx="0">
+            <a:schemeClr val="accent1"/>
+          </a:effectRef>
+          <a:fontRef idx="minor">
+            <a:schemeClr val="lt1"/>
+          </a:fontRef>
+        </p:style>
+        <p:txBody>
+          <a:bodyPr rtlCol="0" anchor="ctr"/>
+          <a:lstStyle/>
+          <a:p>
+            <a:pPr algn="ctr"/>
+            <a:r>
+              <a:rPr lang="en-US" sz="600" dirty="0">
+                <a:ln w="0"/>
+                <a:solidFill>
+                  <a:schemeClr val="tx1"/>
+                </a:solidFill>
+                <a:effectLst>
+                  <a:outerShdw blurRad="38100" dist="19050" dir="2700000" algn="tl" rotWithShape="0">
+                    <a:schemeClr val="dk1">
+                      <a:alpha val="40000"/>
+                    </a:schemeClr>
+                  </a:outerShdw>
+                </a:effectLst>
+              </a:rPr>
+              <a:t>Output Chan 1</a:t>
+            </a:r>
+          </a:p>
+        </p:txBody>
+      </p:sp>
+      <p:sp>
+        <p:nvSpPr>
+          <p:cNvPr id="31" name="Rectangle 30">
+            <a:extLst>
+              <a:ext uri="{FF2B5EF4-FFF2-40B4-BE49-F238E27FC236}">
+                <a16:creationId xmlns:a16="http://schemas.microsoft.com/office/drawing/2014/main" id="{4ACA9710-F20C-A307-6BC9-341B12BC4BE1}"/>
+              </a:ext>
+            </a:extLst>
+          </p:cNvPr>
+          <p:cNvSpPr/>
+          <p:nvPr/>
+        </p:nvSpPr>
+        <p:spPr>
+          <a:xfrm>
+            <a:off x="10146296" y="3344242"/>
+            <a:ext cx="450547" cy="233310"/>
+          </a:xfrm>
+          <a:prstGeom prst="rect">
+            <a:avLst/>
+          </a:prstGeom>
+          <a:solidFill>
+            <a:srgbClr val="FFFF00"/>
+          </a:solidFill>
+          <a:ln>
+            <a:noFill/>
+          </a:ln>
+        </p:spPr>
+        <p:style>
+          <a:lnRef idx="2">
+            <a:schemeClr val="accent1">
+              <a:shade val="15000"/>
+            </a:schemeClr>
+          </a:lnRef>
+          <a:fillRef idx="1">
+            <a:schemeClr val="accent1"/>
+          </a:fillRef>
+          <a:effectRef idx="0">
+            <a:schemeClr val="accent1"/>
+          </a:effectRef>
+          <a:fontRef idx="minor">
+            <a:schemeClr val="lt1"/>
+          </a:fontRef>
+        </p:style>
+        <p:txBody>
+          <a:bodyPr rtlCol="0" anchor="ctr"/>
+          <a:lstStyle/>
+          <a:p>
+            <a:pPr algn="ctr"/>
+            <a:r>
+              <a:rPr lang="en-US" sz="600" dirty="0">
+                <a:ln w="0"/>
+                <a:solidFill>
+                  <a:schemeClr val="tx1"/>
+                </a:solidFill>
+                <a:effectLst>
+                  <a:outerShdw blurRad="38100" dist="19050" dir="2700000" algn="tl" rotWithShape="0">
+                    <a:schemeClr val="dk1">
+                      <a:alpha val="40000"/>
+                    </a:schemeClr>
+                  </a:outerShdw>
+                </a:effectLst>
+              </a:rPr>
+              <a:t>Output Chan 2</a:t>
+            </a:r>
+          </a:p>
+        </p:txBody>
+      </p:sp>
+      <p:sp>
+        <p:nvSpPr>
+          <p:cNvPr id="32" name="Rectangle 31">
+            <a:extLst>
+              <a:ext uri="{FF2B5EF4-FFF2-40B4-BE49-F238E27FC236}">
+                <a16:creationId xmlns:a16="http://schemas.microsoft.com/office/drawing/2014/main" id="{86B2DF49-70AA-1648-13C9-7DEC7873CC31}"/>
+              </a:ext>
+            </a:extLst>
+          </p:cNvPr>
+          <p:cNvSpPr/>
+          <p:nvPr/>
+        </p:nvSpPr>
+        <p:spPr>
+          <a:xfrm>
+            <a:off x="9373207" y="2550488"/>
+            <a:ext cx="506552" cy="273134"/>
+          </a:xfrm>
+          <a:prstGeom prst="rect">
+            <a:avLst/>
+          </a:prstGeom>
+          <a:solidFill>
+            <a:srgbClr val="FFFF00"/>
+          </a:solidFill>
+          <a:ln>
+            <a:noFill/>
+          </a:ln>
+        </p:spPr>
+        <p:style>
+          <a:lnRef idx="2">
+            <a:schemeClr val="accent1">
+              <a:shade val="15000"/>
+            </a:schemeClr>
+          </a:lnRef>
+          <a:fillRef idx="1">
+            <a:schemeClr val="accent1"/>
+          </a:fillRef>
+          <a:effectRef idx="0">
+            <a:schemeClr val="accent1"/>
+          </a:effectRef>
+          <a:fontRef idx="minor">
+            <a:schemeClr val="lt1"/>
+          </a:fontRef>
+        </p:style>
+        <p:txBody>
+          <a:bodyPr rtlCol="0" anchor="ctr"/>
+          <a:lstStyle/>
+          <a:p>
+            <a:pPr algn="ctr"/>
+            <a:r>
+              <a:rPr lang="en-US" sz="600" dirty="0">
+                <a:ln w="0"/>
+                <a:solidFill>
+                  <a:schemeClr val="tx1"/>
+                </a:solidFill>
+                <a:effectLst>
+                  <a:outerShdw blurRad="38100" dist="19050" dir="2700000" algn="tl" rotWithShape="0">
+                    <a:schemeClr val="dk1">
+                      <a:alpha val="40000"/>
+                    </a:schemeClr>
+                  </a:outerShdw>
+                </a:effectLst>
+              </a:rPr>
+              <a:t>Radiate (neighbor level)</a:t>
+            </a:r>
+          </a:p>
+        </p:txBody>
+      </p:sp>
+      <p:sp>
+        <p:nvSpPr>
+          <p:cNvPr id="33" name="Rectangle 32">
+            <a:extLst>
+              <a:ext uri="{FF2B5EF4-FFF2-40B4-BE49-F238E27FC236}">
+                <a16:creationId xmlns:a16="http://schemas.microsoft.com/office/drawing/2014/main" id="{8DD99B67-7DEB-6015-E9A8-F2C28DC5DFD8}"/>
+              </a:ext>
+            </a:extLst>
+          </p:cNvPr>
+          <p:cNvSpPr/>
+          <p:nvPr/>
+        </p:nvSpPr>
+        <p:spPr>
+          <a:xfrm>
+            <a:off x="9614139" y="3967401"/>
+            <a:ext cx="531240" cy="291991"/>
+          </a:xfrm>
+          <a:prstGeom prst="rect">
+            <a:avLst/>
+          </a:prstGeom>
+          <a:solidFill>
+            <a:srgbClr val="7030A0"/>
+          </a:solidFill>
+          <a:ln>
+            <a:noFill/>
+          </a:ln>
+        </p:spPr>
+        <p:style>
+          <a:lnRef idx="2">
+            <a:schemeClr val="accent1">
+              <a:shade val="15000"/>
+            </a:schemeClr>
+          </a:lnRef>
+          <a:fillRef idx="1">
+            <a:schemeClr val="accent1"/>
+          </a:fillRef>
+          <a:effectRef idx="0">
+            <a:schemeClr val="accent1"/>
+          </a:effectRef>
+          <a:fontRef idx="minor">
+            <a:schemeClr val="lt1"/>
+          </a:fontRef>
+        </p:style>
+        <p:txBody>
+          <a:bodyPr rtlCol="0" anchor="ctr"/>
+          <a:lstStyle/>
+          <a:p>
+            <a:pPr algn="ctr"/>
+            <a:r>
+              <a:rPr lang="en-US" sz="600" dirty="0">
+                <a:ln w="0"/>
+                <a:solidFill>
+                  <a:schemeClr val="bg1"/>
+                </a:solidFill>
+                <a:effectLst>
+                  <a:outerShdw blurRad="38100" dist="19050" dir="2700000" algn="tl" rotWithShape="0">
+                    <a:schemeClr val="dk1">
+                      <a:alpha val="40000"/>
+                    </a:schemeClr>
+                  </a:outerShdw>
+                </a:effectLst>
+              </a:rPr>
+              <a:t>Turing  Output</a:t>
+            </a:r>
+          </a:p>
+        </p:txBody>
+      </p:sp>
+      <p:sp>
+        <p:nvSpPr>
+          <p:cNvPr id="34" name="Rectangle 33">
+            <a:extLst>
+              <a:ext uri="{FF2B5EF4-FFF2-40B4-BE49-F238E27FC236}">
+                <a16:creationId xmlns:a16="http://schemas.microsoft.com/office/drawing/2014/main" id="{48153D38-F8CB-3738-A92B-6B266439ECA4}"/>
+              </a:ext>
+            </a:extLst>
+          </p:cNvPr>
+          <p:cNvSpPr/>
+          <p:nvPr/>
+        </p:nvSpPr>
+        <p:spPr>
+          <a:xfrm>
+            <a:off x="10168277" y="3989462"/>
+            <a:ext cx="385059" cy="233310"/>
+          </a:xfrm>
+          <a:prstGeom prst="rect">
+            <a:avLst/>
+          </a:prstGeom>
+          <a:solidFill>
+            <a:srgbClr val="FFFF00"/>
+          </a:solidFill>
+          <a:ln>
+            <a:noFill/>
+          </a:ln>
+        </p:spPr>
+        <p:style>
+          <a:lnRef idx="2">
+            <a:schemeClr val="accent1">
+              <a:shade val="15000"/>
+            </a:schemeClr>
+          </a:lnRef>
+          <a:fillRef idx="1">
+            <a:schemeClr val="accent1"/>
+          </a:fillRef>
+          <a:effectRef idx="0">
+            <a:schemeClr val="accent1"/>
+          </a:effectRef>
+          <a:fontRef idx="minor">
+            <a:schemeClr val="lt1"/>
+          </a:fontRef>
+        </p:style>
+        <p:txBody>
+          <a:bodyPr rtlCol="0" anchor="ctr"/>
+          <a:lstStyle/>
+          <a:p>
+            <a:pPr algn="ctr"/>
+            <a:r>
+              <a:rPr lang="en-US" sz="600" dirty="0">
+                <a:ln w="0"/>
+                <a:solidFill>
+                  <a:schemeClr val="tx1"/>
+                </a:solidFill>
+                <a:effectLst>
+                  <a:outerShdw blurRad="38100" dist="19050" dir="2700000" algn="tl" rotWithShape="0">
+                    <a:schemeClr val="dk1">
+                      <a:alpha val="40000"/>
+                    </a:schemeClr>
+                  </a:outerShdw>
+                </a:effectLst>
+              </a:rPr>
+              <a:t>AD Env</a:t>
+            </a:r>
+          </a:p>
+        </p:txBody>
+      </p:sp>
+      <p:sp>
+        <p:nvSpPr>
+          <p:cNvPr id="38" name="Rectangle 37">
+            <a:extLst>
+              <a:ext uri="{FF2B5EF4-FFF2-40B4-BE49-F238E27FC236}">
+                <a16:creationId xmlns:a16="http://schemas.microsoft.com/office/drawing/2014/main" id="{A9BF5240-D3E6-E185-E8F9-F86F5B2AE9E0}"/>
+              </a:ext>
+            </a:extLst>
+          </p:cNvPr>
+          <p:cNvSpPr/>
+          <p:nvPr/>
+        </p:nvSpPr>
+        <p:spPr>
+          <a:xfrm>
+            <a:off x="8712672" y="4599072"/>
+            <a:ext cx="444020" cy="293272"/>
+          </a:xfrm>
+          <a:prstGeom prst="rect">
+            <a:avLst/>
+          </a:prstGeom>
+          <a:solidFill>
+            <a:srgbClr val="FFFF00"/>
+          </a:solidFill>
+          <a:ln>
+            <a:noFill/>
+          </a:ln>
+        </p:spPr>
+        <p:style>
+          <a:lnRef idx="2">
+            <a:schemeClr val="accent1">
+              <a:shade val="15000"/>
+            </a:schemeClr>
+          </a:lnRef>
+          <a:fillRef idx="1">
+            <a:schemeClr val="accent1"/>
+          </a:fillRef>
+          <a:effectRef idx="0">
+            <a:schemeClr val="accent1"/>
+          </a:effectRef>
+          <a:fontRef idx="minor">
+            <a:schemeClr val="lt1"/>
+          </a:fontRef>
+        </p:style>
+        <p:txBody>
+          <a:bodyPr rtlCol="0" anchor="ctr"/>
+          <a:lstStyle/>
+          <a:p>
+            <a:pPr algn="ctr"/>
+            <a:r>
+              <a:rPr lang="en-US" sz="600" dirty="0">
+                <a:ln w="0"/>
+                <a:solidFill>
+                  <a:schemeClr val="tx1"/>
+                </a:solidFill>
+                <a:effectLst>
+                  <a:outerShdw blurRad="38100" dist="19050" dir="2700000" algn="tl" rotWithShape="0">
+                    <a:schemeClr val="dk1">
+                      <a:alpha val="40000"/>
+                    </a:schemeClr>
+                  </a:outerShdw>
+                </a:effectLst>
+              </a:rPr>
+              <a:t>Reset Active Track</a:t>
+            </a:r>
+          </a:p>
+        </p:txBody>
+      </p:sp>
+      <p:sp>
+        <p:nvSpPr>
+          <p:cNvPr id="39" name="Rectangle 38">
+            <a:extLst>
+              <a:ext uri="{FF2B5EF4-FFF2-40B4-BE49-F238E27FC236}">
+                <a16:creationId xmlns:a16="http://schemas.microsoft.com/office/drawing/2014/main" id="{1C14ED5A-7665-2F29-8D5C-8355BB8F41C4}"/>
+              </a:ext>
+            </a:extLst>
+          </p:cNvPr>
+          <p:cNvSpPr/>
+          <p:nvPr/>
+        </p:nvSpPr>
+        <p:spPr>
+          <a:xfrm>
+            <a:off x="9196328" y="4598502"/>
+            <a:ext cx="444019" cy="293272"/>
+          </a:xfrm>
+          <a:prstGeom prst="rect">
+            <a:avLst/>
+          </a:prstGeom>
+          <a:solidFill>
+            <a:srgbClr val="FFFF00"/>
+          </a:solidFill>
+          <a:ln>
+            <a:noFill/>
+          </a:ln>
+        </p:spPr>
+        <p:style>
+          <a:lnRef idx="2">
+            <a:schemeClr val="accent1">
+              <a:shade val="15000"/>
+            </a:schemeClr>
+          </a:lnRef>
+          <a:fillRef idx="1">
+            <a:schemeClr val="accent1"/>
+          </a:fillRef>
+          <a:effectRef idx="0">
+            <a:schemeClr val="accent1"/>
+          </a:effectRef>
+          <a:fontRef idx="minor">
+            <a:schemeClr val="lt1"/>
+          </a:fontRef>
+        </p:style>
+        <p:txBody>
+          <a:bodyPr rtlCol="0" anchor="ctr"/>
+          <a:lstStyle/>
+          <a:p>
+            <a:pPr algn="ctr"/>
+            <a:r>
+              <a:rPr lang="en-US" sz="600" dirty="0">
+                <a:ln w="0"/>
+                <a:solidFill>
+                  <a:schemeClr val="tx1"/>
+                </a:solidFill>
+                <a:effectLst>
+                  <a:outerShdw blurRad="38100" dist="19050" dir="2700000" algn="tl" rotWithShape="0">
+                    <a:schemeClr val="dk1">
+                      <a:alpha val="40000"/>
+                    </a:schemeClr>
+                  </a:outerShdw>
+                </a:effectLst>
+              </a:rPr>
+              <a:t>Next Active Track</a:t>
+            </a:r>
+          </a:p>
+        </p:txBody>
+      </p:sp>
+      <p:sp>
+        <p:nvSpPr>
+          <p:cNvPr id="40" name="Rectangle 39">
+            <a:extLst>
+              <a:ext uri="{FF2B5EF4-FFF2-40B4-BE49-F238E27FC236}">
+                <a16:creationId xmlns:a16="http://schemas.microsoft.com/office/drawing/2014/main" id="{316261D3-12ED-88DE-1119-69CEFF34C1DE}"/>
+              </a:ext>
+            </a:extLst>
+          </p:cNvPr>
+          <p:cNvSpPr/>
+          <p:nvPr/>
+        </p:nvSpPr>
+        <p:spPr>
+          <a:xfrm>
+            <a:off x="9661907" y="4619803"/>
+            <a:ext cx="444019" cy="275912"/>
+          </a:xfrm>
+          <a:prstGeom prst="rect">
+            <a:avLst/>
+          </a:prstGeom>
+          <a:solidFill>
+            <a:srgbClr val="FFFF00"/>
+          </a:solidFill>
+          <a:ln>
+            <a:noFill/>
+          </a:ln>
+        </p:spPr>
+        <p:style>
+          <a:lnRef idx="2">
+            <a:schemeClr val="accent1">
+              <a:shade val="15000"/>
+            </a:schemeClr>
+          </a:lnRef>
+          <a:fillRef idx="1">
+            <a:schemeClr val="accent1"/>
+          </a:fillRef>
+          <a:effectRef idx="0">
+            <a:schemeClr val="accent1"/>
+          </a:effectRef>
+          <a:fontRef idx="minor">
+            <a:schemeClr val="lt1"/>
+          </a:fontRef>
+        </p:style>
+        <p:txBody>
+          <a:bodyPr rtlCol="0" anchor="ctr"/>
+          <a:lstStyle/>
+          <a:p>
+            <a:pPr algn="ctr"/>
+            <a:r>
+              <a:rPr lang="en-US" sz="600" dirty="0">
+                <a:ln w="0"/>
+                <a:solidFill>
+                  <a:schemeClr val="tx1"/>
+                </a:solidFill>
+                <a:effectLst>
+                  <a:outerShdw blurRad="38100" dist="19050" dir="2700000" algn="tl" rotWithShape="0">
+                    <a:schemeClr val="dk1">
+                      <a:alpha val="40000"/>
+                    </a:schemeClr>
+                  </a:outerShdw>
+                </a:effectLst>
+              </a:rPr>
+              <a:t>Track end Trig</a:t>
+            </a:r>
+          </a:p>
+        </p:txBody>
+      </p:sp>
+      <p:sp>
+        <p:nvSpPr>
+          <p:cNvPr id="44" name="Rectangle 43">
+            <a:extLst>
+              <a:ext uri="{FF2B5EF4-FFF2-40B4-BE49-F238E27FC236}">
+                <a16:creationId xmlns:a16="http://schemas.microsoft.com/office/drawing/2014/main" id="{E8BBFEAD-6CDA-E49B-B99C-47675A6E8DAC}"/>
+              </a:ext>
+            </a:extLst>
+          </p:cNvPr>
+          <p:cNvSpPr/>
+          <p:nvPr/>
+        </p:nvSpPr>
+        <p:spPr>
+          <a:xfrm>
+            <a:off x="10127486" y="4611023"/>
+            <a:ext cx="444019" cy="293272"/>
+          </a:xfrm>
+          <a:prstGeom prst="rect">
+            <a:avLst/>
+          </a:prstGeom>
+          <a:solidFill>
+            <a:srgbClr val="FFFF00"/>
+          </a:solidFill>
+          <a:ln>
+            <a:noFill/>
+          </a:ln>
+        </p:spPr>
+        <p:style>
+          <a:lnRef idx="2">
+            <a:schemeClr val="accent1">
+              <a:shade val="15000"/>
+            </a:schemeClr>
+          </a:lnRef>
+          <a:fillRef idx="1">
+            <a:schemeClr val="accent1"/>
+          </a:fillRef>
+          <a:effectRef idx="0">
+            <a:schemeClr val="accent1"/>
+          </a:effectRef>
+          <a:fontRef idx="minor">
+            <a:schemeClr val="lt1"/>
+          </a:fontRef>
+        </p:style>
+        <p:txBody>
+          <a:bodyPr rtlCol="0" anchor="ctr"/>
+          <a:lstStyle/>
+          <a:p>
+            <a:pPr algn="ctr"/>
+            <a:r>
+              <a:rPr lang="en-US" sz="600" dirty="0">
+                <a:ln w="0"/>
+                <a:solidFill>
+                  <a:schemeClr val="tx1"/>
+                </a:solidFill>
+                <a:effectLst>
+                  <a:outerShdw blurRad="38100" dist="19050" dir="2700000" algn="tl" rotWithShape="0">
+                    <a:schemeClr val="dk1">
+                      <a:alpha val="40000"/>
+                    </a:schemeClr>
+                  </a:outerShdw>
+                </a:effectLst>
+              </a:rPr>
+              <a:t>Env end of cycle trig</a:t>
+            </a:r>
+          </a:p>
+        </p:txBody>
+      </p:sp>
+      <p:sp>
+        <p:nvSpPr>
+          <p:cNvPr id="45" name="Rectangle 44">
+            <a:extLst>
+              <a:ext uri="{FF2B5EF4-FFF2-40B4-BE49-F238E27FC236}">
+                <a16:creationId xmlns:a16="http://schemas.microsoft.com/office/drawing/2014/main" id="{8B665E3C-BE27-02C1-8CB6-BF8A1B72FEEA}"/>
+              </a:ext>
+            </a:extLst>
+          </p:cNvPr>
+          <p:cNvSpPr/>
+          <p:nvPr/>
+        </p:nvSpPr>
+        <p:spPr>
+          <a:xfrm>
+            <a:off x="9323616" y="2331487"/>
+            <a:ext cx="592317" cy="233310"/>
+          </a:xfrm>
+          <a:prstGeom prst="rect">
+            <a:avLst/>
+          </a:prstGeom>
+          <a:solidFill>
+            <a:schemeClr val="accent4"/>
+          </a:solidFill>
+          <a:ln>
+            <a:noFill/>
+          </a:ln>
+        </p:spPr>
+        <p:style>
+          <a:lnRef idx="2">
+            <a:schemeClr val="accent1">
+              <a:shade val="15000"/>
+            </a:schemeClr>
+          </a:lnRef>
+          <a:fillRef idx="1">
+            <a:schemeClr val="accent1"/>
+          </a:fillRef>
+          <a:effectRef idx="0">
+            <a:schemeClr val="accent1"/>
+          </a:effectRef>
+          <a:fontRef idx="minor">
+            <a:schemeClr val="lt1"/>
+          </a:fontRef>
+        </p:style>
+        <p:txBody>
+          <a:bodyPr rtlCol="0" anchor="ctr"/>
+          <a:lstStyle/>
+          <a:p>
+            <a:pPr algn="ctr"/>
+            <a:r>
+              <a:rPr lang="en-US" sz="600" dirty="0">
+                <a:ln w="0"/>
+                <a:solidFill>
+                  <a:schemeClr val="bg1"/>
+                </a:solidFill>
+                <a:effectLst>
+                  <a:outerShdw blurRad="38100" dist="19050" dir="2700000" algn="tl" rotWithShape="0">
+                    <a:schemeClr val="dk1">
+                      <a:alpha val="40000"/>
+                    </a:schemeClr>
+                  </a:outerShdw>
+                </a:effectLst>
+              </a:rPr>
+              <a:t>Active Track Start point</a:t>
+            </a:r>
+          </a:p>
+        </p:txBody>
+      </p:sp>
+      <p:sp>
+        <p:nvSpPr>
+          <p:cNvPr id="46" name="Rectangle 45">
+            <a:extLst>
+              <a:ext uri="{FF2B5EF4-FFF2-40B4-BE49-F238E27FC236}">
+                <a16:creationId xmlns:a16="http://schemas.microsoft.com/office/drawing/2014/main" id="{0CEBC3EC-FF01-7128-1BF8-17BB73B2CFC4}"/>
+              </a:ext>
+            </a:extLst>
+          </p:cNvPr>
+          <p:cNvSpPr/>
+          <p:nvPr/>
+        </p:nvSpPr>
+        <p:spPr>
+          <a:xfrm>
+            <a:off x="8696907" y="2269566"/>
+            <a:ext cx="592317" cy="233310"/>
+          </a:xfrm>
+          <a:prstGeom prst="rect">
+            <a:avLst/>
+          </a:prstGeom>
+          <a:solidFill>
+            <a:schemeClr val="accent4"/>
+          </a:solidFill>
+          <a:ln>
+            <a:noFill/>
+          </a:ln>
+        </p:spPr>
+        <p:style>
+          <a:lnRef idx="2">
+            <a:schemeClr val="accent1">
+              <a:shade val="15000"/>
+            </a:schemeClr>
+          </a:lnRef>
+          <a:fillRef idx="1">
+            <a:schemeClr val="accent1"/>
+          </a:fillRef>
+          <a:effectRef idx="0">
+            <a:schemeClr val="accent1"/>
+          </a:effectRef>
+          <a:fontRef idx="minor">
+            <a:schemeClr val="lt1"/>
+          </a:fontRef>
+        </p:style>
+        <p:txBody>
+          <a:bodyPr rtlCol="0" anchor="ctr"/>
+          <a:lstStyle/>
+          <a:p>
+            <a:pPr algn="ctr"/>
+            <a:r>
+              <a:rPr lang="en-US" sz="600" dirty="0">
+                <a:ln w="0"/>
+                <a:solidFill>
+                  <a:schemeClr val="bg1"/>
+                </a:solidFill>
+                <a:effectLst>
+                  <a:outerShdw blurRad="38100" dist="19050" dir="2700000" algn="tl" rotWithShape="0">
+                    <a:schemeClr val="dk1">
+                      <a:alpha val="40000"/>
+                    </a:schemeClr>
+                  </a:outerShdw>
+                </a:effectLst>
+              </a:rPr>
+              <a:t>Active Track pre-mix gain</a:t>
+            </a:r>
+          </a:p>
+        </p:txBody>
+      </p:sp>
+      <p:sp>
+        <p:nvSpPr>
+          <p:cNvPr id="47" name="Rectangle 46">
+            <a:extLst>
+              <a:ext uri="{FF2B5EF4-FFF2-40B4-BE49-F238E27FC236}">
+                <a16:creationId xmlns:a16="http://schemas.microsoft.com/office/drawing/2014/main" id="{FFF40C4A-8104-E04A-5D12-716BE106225C}"/>
+              </a:ext>
+            </a:extLst>
+          </p:cNvPr>
+          <p:cNvSpPr/>
+          <p:nvPr/>
+        </p:nvSpPr>
+        <p:spPr>
+          <a:xfrm>
+            <a:off x="9165448" y="980141"/>
+            <a:ext cx="995818" cy="493362"/>
+          </a:xfrm>
+          <a:prstGeom prst="rect">
+            <a:avLst/>
+          </a:prstGeom>
+          <a:solidFill>
+            <a:schemeClr val="accent4"/>
+          </a:solidFill>
+          <a:ln>
+            <a:noFill/>
+          </a:ln>
+        </p:spPr>
+        <p:style>
+          <a:lnRef idx="2">
+            <a:schemeClr val="accent1">
+              <a:shade val="15000"/>
+            </a:schemeClr>
+          </a:lnRef>
+          <a:fillRef idx="1">
+            <a:schemeClr val="accent1"/>
+          </a:fillRef>
+          <a:effectRef idx="0">
+            <a:schemeClr val="accent1"/>
+          </a:effectRef>
+          <a:fontRef idx="minor">
+            <a:schemeClr val="lt1"/>
+          </a:fontRef>
+        </p:style>
+        <p:txBody>
+          <a:bodyPr rtlCol="0" anchor="ctr"/>
+          <a:lstStyle/>
+          <a:p>
+            <a:pPr algn="ctr"/>
+            <a:r>
+              <a:rPr lang="en-US" sz="900" dirty="0">
+                <a:ln w="0"/>
+                <a:solidFill>
+                  <a:schemeClr val="bg1"/>
+                </a:solidFill>
+                <a:effectLst>
+                  <a:outerShdw blurRad="38100" dist="19050" dir="2700000" algn="tl" rotWithShape="0">
+                    <a:schemeClr val="dk1">
+                      <a:alpha val="40000"/>
+                    </a:schemeClr>
+                  </a:outerShdw>
+                </a:effectLst>
+              </a:rPr>
+              <a:t>Active Track speed/direction</a:t>
+            </a:r>
+          </a:p>
+        </p:txBody>
+      </p:sp>
+      <p:sp>
+        <p:nvSpPr>
+          <p:cNvPr id="48" name="Rectangle 47">
+            <a:extLst>
+              <a:ext uri="{FF2B5EF4-FFF2-40B4-BE49-F238E27FC236}">
+                <a16:creationId xmlns:a16="http://schemas.microsoft.com/office/drawing/2014/main" id="{4E80D56C-D3B3-FBBE-E644-94994F4A5D19}"/>
+              </a:ext>
+            </a:extLst>
+          </p:cNvPr>
+          <p:cNvSpPr/>
+          <p:nvPr/>
+        </p:nvSpPr>
+        <p:spPr>
+          <a:xfrm>
+            <a:off x="8687085" y="3960121"/>
+            <a:ext cx="444021" cy="291991"/>
+          </a:xfrm>
+          <a:prstGeom prst="rect">
+            <a:avLst/>
+          </a:prstGeom>
+          <a:solidFill>
+            <a:srgbClr val="FFFF00"/>
+          </a:solidFill>
+          <a:ln>
+            <a:noFill/>
+          </a:ln>
+        </p:spPr>
+        <p:style>
+          <a:lnRef idx="2">
+            <a:schemeClr val="accent1">
+              <a:shade val="15000"/>
+            </a:schemeClr>
+          </a:lnRef>
+          <a:fillRef idx="1">
+            <a:schemeClr val="accent1"/>
+          </a:fillRef>
+          <a:effectRef idx="0">
+            <a:schemeClr val="accent1"/>
+          </a:effectRef>
+          <a:fontRef idx="minor">
+            <a:schemeClr val="lt1"/>
+          </a:fontRef>
+        </p:style>
+        <p:txBody>
+          <a:bodyPr rtlCol="0" anchor="ctr"/>
+          <a:lstStyle/>
+          <a:p>
+            <a:pPr algn="ctr"/>
+            <a:r>
+              <a:rPr lang="en-US" sz="600" dirty="0">
+                <a:ln w="0"/>
+                <a:solidFill>
+                  <a:schemeClr val="tx1"/>
+                </a:solidFill>
+                <a:effectLst>
+                  <a:outerShdw blurRad="38100" dist="19050" dir="2700000" algn="tl" rotWithShape="0">
+                    <a:schemeClr val="dk1">
+                      <a:alpha val="40000"/>
+                    </a:schemeClr>
+                  </a:outerShdw>
+                </a:effectLst>
+              </a:rPr>
+              <a:t>Mod X (either mode)</a:t>
+            </a:r>
+          </a:p>
+        </p:txBody>
+      </p:sp>
+      <p:sp>
+        <p:nvSpPr>
+          <p:cNvPr id="49" name="Rectangle 48">
+            <a:extLst>
+              <a:ext uri="{FF2B5EF4-FFF2-40B4-BE49-F238E27FC236}">
+                <a16:creationId xmlns:a16="http://schemas.microsoft.com/office/drawing/2014/main" id="{262E047D-E785-6819-D6FE-35E2649F2920}"/>
+              </a:ext>
+            </a:extLst>
+          </p:cNvPr>
+          <p:cNvSpPr/>
+          <p:nvPr/>
+        </p:nvSpPr>
+        <p:spPr>
+          <a:xfrm>
+            <a:off x="9156245" y="3965912"/>
+            <a:ext cx="444021" cy="291991"/>
+          </a:xfrm>
+          <a:prstGeom prst="rect">
+            <a:avLst/>
+          </a:prstGeom>
+          <a:solidFill>
+            <a:srgbClr val="FFFF00"/>
+          </a:solidFill>
+          <a:ln>
+            <a:noFill/>
+          </a:ln>
+        </p:spPr>
+        <p:style>
+          <a:lnRef idx="2">
+            <a:schemeClr val="accent1">
+              <a:shade val="15000"/>
+            </a:schemeClr>
+          </a:lnRef>
+          <a:fillRef idx="1">
+            <a:schemeClr val="accent1"/>
+          </a:fillRef>
+          <a:effectRef idx="0">
+            <a:schemeClr val="accent1"/>
+          </a:effectRef>
+          <a:fontRef idx="minor">
+            <a:schemeClr val="lt1"/>
+          </a:fontRef>
+        </p:style>
+        <p:txBody>
+          <a:bodyPr rtlCol="0" anchor="ctr"/>
+          <a:lstStyle/>
+          <a:p>
+            <a:pPr algn="ctr"/>
+            <a:r>
+              <a:rPr lang="en-US" sz="600" dirty="0">
+                <a:ln w="0"/>
+                <a:solidFill>
+                  <a:schemeClr val="tx1"/>
+                </a:solidFill>
+                <a:effectLst>
+                  <a:outerShdw blurRad="38100" dist="19050" dir="2700000" algn="tl" rotWithShape="0">
+                    <a:schemeClr val="dk1">
+                      <a:alpha val="40000"/>
+                    </a:schemeClr>
+                  </a:outerShdw>
+                </a:effectLst>
+              </a:rPr>
+              <a:t>Mod Y (either mode)</a:t>
+            </a:r>
+          </a:p>
+        </p:txBody>
+      </p:sp>
+      <p:sp>
+        <p:nvSpPr>
+          <p:cNvPr id="50" name="Rectangle 49">
+            <a:extLst>
+              <a:ext uri="{FF2B5EF4-FFF2-40B4-BE49-F238E27FC236}">
+                <a16:creationId xmlns:a16="http://schemas.microsoft.com/office/drawing/2014/main" id="{74DCE2EC-8F8E-A9FD-9400-C27CC7D77124}"/>
+              </a:ext>
+            </a:extLst>
+          </p:cNvPr>
+          <p:cNvSpPr/>
+          <p:nvPr/>
+        </p:nvSpPr>
+        <p:spPr>
+          <a:xfrm>
+            <a:off x="10161266" y="1338843"/>
+            <a:ext cx="531240" cy="291991"/>
+          </a:xfrm>
+          <a:prstGeom prst="rect">
+            <a:avLst/>
+          </a:prstGeom>
+          <a:solidFill>
+            <a:srgbClr val="7030A0"/>
+          </a:solidFill>
+          <a:ln>
+            <a:noFill/>
+          </a:ln>
+        </p:spPr>
+        <p:style>
+          <a:lnRef idx="2">
+            <a:schemeClr val="accent1">
+              <a:shade val="15000"/>
+            </a:schemeClr>
+          </a:lnRef>
+          <a:fillRef idx="1">
+            <a:schemeClr val="accent1"/>
+          </a:fillRef>
+          <a:effectRef idx="0">
+            <a:schemeClr val="accent1"/>
+          </a:effectRef>
+          <a:fontRef idx="minor">
+            <a:schemeClr val="lt1"/>
+          </a:fontRef>
+        </p:style>
+        <p:txBody>
+          <a:bodyPr rtlCol="0" anchor="ctr"/>
+          <a:lstStyle/>
+          <a:p>
+            <a:pPr algn="ctr"/>
+            <a:r>
+              <a:rPr lang="en-US" sz="600" dirty="0">
+                <a:ln w="0"/>
+                <a:solidFill>
+                  <a:schemeClr val="bg1"/>
+                </a:solidFill>
+                <a:effectLst>
+                  <a:outerShdw blurRad="38100" dist="19050" dir="2700000" algn="tl" rotWithShape="0">
+                    <a:schemeClr val="dk1">
+                      <a:alpha val="40000"/>
+                    </a:schemeClr>
+                  </a:outerShdw>
+                </a:effectLst>
+              </a:rPr>
+              <a:t>Turing  Big Knob</a:t>
+            </a:r>
+          </a:p>
+        </p:txBody>
+      </p:sp>
+      <p:sp>
+        <p:nvSpPr>
+          <p:cNvPr id="51" name="Rectangle 50">
+            <a:extLst>
+              <a:ext uri="{FF2B5EF4-FFF2-40B4-BE49-F238E27FC236}">
+                <a16:creationId xmlns:a16="http://schemas.microsoft.com/office/drawing/2014/main" id="{9FF6419B-F1E1-6050-A1AF-0C239ED2FF73}"/>
+              </a:ext>
+            </a:extLst>
+          </p:cNvPr>
+          <p:cNvSpPr/>
+          <p:nvPr/>
+        </p:nvSpPr>
+        <p:spPr>
+          <a:xfrm>
+            <a:off x="8747291" y="2949765"/>
+            <a:ext cx="531240" cy="291991"/>
+          </a:xfrm>
+          <a:prstGeom prst="rect">
+            <a:avLst/>
+          </a:prstGeom>
+          <a:solidFill>
+            <a:srgbClr val="7030A0"/>
+          </a:solidFill>
+          <a:ln>
+            <a:noFill/>
+          </a:ln>
+        </p:spPr>
+        <p:style>
+          <a:lnRef idx="2">
+            <a:schemeClr val="accent1">
+              <a:shade val="15000"/>
+            </a:schemeClr>
+          </a:lnRef>
+          <a:fillRef idx="1">
+            <a:schemeClr val="accent1"/>
+          </a:fillRef>
+          <a:effectRef idx="0">
+            <a:schemeClr val="accent1"/>
+          </a:effectRef>
+          <a:fontRef idx="minor">
+            <a:schemeClr val="lt1"/>
+          </a:fontRef>
+        </p:style>
+        <p:txBody>
+          <a:bodyPr rtlCol="0" anchor="ctr"/>
+          <a:lstStyle/>
+          <a:p>
+            <a:pPr algn="ctr"/>
+            <a:r>
+              <a:rPr lang="en-US" sz="600" dirty="0">
+                <a:ln w="0"/>
+                <a:solidFill>
+                  <a:schemeClr val="bg1"/>
+                </a:solidFill>
+                <a:effectLst>
+                  <a:outerShdw blurRad="38100" dist="19050" dir="2700000" algn="tl" rotWithShape="0">
+                    <a:schemeClr val="dk1">
+                      <a:alpha val="40000"/>
+                    </a:schemeClr>
+                  </a:outerShdw>
+                </a:effectLst>
+              </a:rPr>
+              <a:t>Turing range</a:t>
+            </a:r>
+          </a:p>
+        </p:txBody>
+      </p:sp>
+      <p:sp>
+        <p:nvSpPr>
+          <p:cNvPr id="52" name="Rectangle 51">
+            <a:extLst>
+              <a:ext uri="{FF2B5EF4-FFF2-40B4-BE49-F238E27FC236}">
+                <a16:creationId xmlns:a16="http://schemas.microsoft.com/office/drawing/2014/main" id="{38FEC3A9-E622-1665-C1C8-F66E612FB50C}"/>
+              </a:ext>
+            </a:extLst>
+          </p:cNvPr>
+          <p:cNvSpPr/>
+          <p:nvPr/>
+        </p:nvSpPr>
+        <p:spPr>
+          <a:xfrm>
+            <a:off x="9360863" y="2947030"/>
+            <a:ext cx="531240" cy="291991"/>
+          </a:xfrm>
+          <a:prstGeom prst="rect">
+            <a:avLst/>
+          </a:prstGeom>
+          <a:solidFill>
+            <a:srgbClr val="7030A0"/>
+          </a:solidFill>
+          <a:ln>
+            <a:noFill/>
+          </a:ln>
+        </p:spPr>
+        <p:style>
+          <a:lnRef idx="2">
+            <a:schemeClr val="accent1">
+              <a:shade val="15000"/>
+            </a:schemeClr>
+          </a:lnRef>
+          <a:fillRef idx="1">
+            <a:schemeClr val="accent1"/>
+          </a:fillRef>
+          <a:effectRef idx="0">
+            <a:schemeClr val="accent1"/>
+          </a:effectRef>
+          <a:fontRef idx="minor">
+            <a:schemeClr val="lt1"/>
+          </a:fontRef>
+        </p:style>
+        <p:txBody>
+          <a:bodyPr rtlCol="0" anchor="ctr"/>
+          <a:lstStyle/>
+          <a:p>
+            <a:pPr algn="ctr"/>
+            <a:r>
+              <a:rPr lang="en-US" sz="600" dirty="0">
+                <a:ln w="0"/>
+                <a:solidFill>
+                  <a:schemeClr val="bg1"/>
+                </a:solidFill>
+                <a:effectLst>
+                  <a:outerShdw blurRad="38100" dist="19050" dir="2700000" algn="tl" rotWithShape="0">
+                    <a:schemeClr val="dk1">
+                      <a:alpha val="40000"/>
+                    </a:schemeClr>
+                  </a:outerShdw>
+                </a:effectLst>
+              </a:rPr>
+              <a:t>Turing Seq length</a:t>
+            </a:r>
+          </a:p>
+        </p:txBody>
+      </p:sp>
+      <p:sp>
+        <p:nvSpPr>
+          <p:cNvPr id="53" name="TextBox 52">
+            <a:extLst>
+              <a:ext uri="{FF2B5EF4-FFF2-40B4-BE49-F238E27FC236}">
+                <a16:creationId xmlns:a16="http://schemas.microsoft.com/office/drawing/2014/main" id="{BD597F65-6B67-B80C-6013-6C49F5C722CF}"/>
+              </a:ext>
+            </a:extLst>
+          </p:cNvPr>
+          <p:cNvSpPr txBox="1"/>
+          <p:nvPr/>
+        </p:nvSpPr>
+        <p:spPr>
+          <a:xfrm>
+            <a:off x="7636227" y="2492646"/>
+            <a:ext cx="881733" cy="707886"/>
+          </a:xfrm>
+          <a:prstGeom prst="rect">
+            <a:avLst/>
+          </a:prstGeom>
+          <a:noFill/>
+        </p:spPr>
+        <p:txBody>
+          <a:bodyPr wrap="square" rtlCol="0">
+            <a:spAutoFit/>
+          </a:bodyPr>
+          <a:lstStyle/>
+          <a:p>
+            <a:r>
+              <a:rPr lang="en-US" sz="1000" dirty="0">
+                <a:solidFill>
+                  <a:srgbClr val="7030A0"/>
+                </a:solidFill>
+              </a:rPr>
+              <a:t>Turing parameters apply in both modes</a:t>
+            </a:r>
+          </a:p>
+        </p:txBody>
+      </p:sp>
+      <p:sp>
+        <p:nvSpPr>
+          <p:cNvPr id="54" name="Rectangle 53">
+            <a:extLst>
+              <a:ext uri="{FF2B5EF4-FFF2-40B4-BE49-F238E27FC236}">
+                <a16:creationId xmlns:a16="http://schemas.microsoft.com/office/drawing/2014/main" id="{AB0708AB-3FB8-A311-41FE-C902D1979667}"/>
+              </a:ext>
+            </a:extLst>
+          </p:cNvPr>
+          <p:cNvSpPr/>
+          <p:nvPr/>
+        </p:nvSpPr>
+        <p:spPr>
+          <a:xfrm>
+            <a:off x="10562247" y="2832688"/>
+            <a:ext cx="592317" cy="233310"/>
+          </a:xfrm>
+          <a:prstGeom prst="rect">
+            <a:avLst/>
+          </a:prstGeom>
+          <a:solidFill>
+            <a:srgbClr val="C00000"/>
+          </a:solidFill>
+          <a:ln>
+            <a:noFill/>
+          </a:ln>
+        </p:spPr>
+        <p:style>
+          <a:lnRef idx="2">
+            <a:schemeClr val="accent1">
+              <a:shade val="15000"/>
+            </a:schemeClr>
+          </a:lnRef>
+          <a:fillRef idx="1">
+            <a:schemeClr val="accent1"/>
+          </a:fillRef>
+          <a:effectRef idx="0">
+            <a:schemeClr val="accent1"/>
+          </a:effectRef>
+          <a:fontRef idx="minor">
+            <a:schemeClr val="lt1"/>
+          </a:fontRef>
+        </p:style>
+        <p:txBody>
+          <a:bodyPr rtlCol="0" anchor="ctr"/>
+          <a:lstStyle/>
+          <a:p>
+            <a:pPr algn="ctr"/>
+            <a:r>
+              <a:rPr lang="en-US" sz="600" dirty="0">
+                <a:ln w="0"/>
+                <a:solidFill>
+                  <a:schemeClr val="bg1"/>
+                </a:solidFill>
+                <a:effectLst>
+                  <a:outerShdw blurRad="38100" dist="19050" dir="2700000" algn="tl" rotWithShape="0">
+                    <a:schemeClr val="dk1">
+                      <a:alpha val="40000"/>
+                    </a:schemeClr>
+                  </a:outerShdw>
+                </a:effectLst>
+              </a:rPr>
+              <a:t>HOLD: Arm recording</a:t>
+            </a:r>
+          </a:p>
+        </p:txBody>
+      </p:sp>
+      <p:sp>
+        <p:nvSpPr>
+          <p:cNvPr id="56" name="Rectangle 55">
+            <a:extLst>
+              <a:ext uri="{FF2B5EF4-FFF2-40B4-BE49-F238E27FC236}">
+                <a16:creationId xmlns:a16="http://schemas.microsoft.com/office/drawing/2014/main" id="{21FA741E-563B-679A-A2D1-C7190B2E513E}"/>
+              </a:ext>
+            </a:extLst>
+          </p:cNvPr>
+          <p:cNvSpPr/>
+          <p:nvPr/>
+        </p:nvSpPr>
+        <p:spPr>
+          <a:xfrm>
+            <a:off x="8699481" y="3508658"/>
+            <a:ext cx="458632" cy="233310"/>
+          </a:xfrm>
+          <a:prstGeom prst="rect">
+            <a:avLst/>
+          </a:prstGeom>
+          <a:solidFill>
+            <a:srgbClr val="C00000"/>
+          </a:solidFill>
+          <a:ln>
+            <a:noFill/>
+          </a:ln>
+        </p:spPr>
+        <p:style>
+          <a:lnRef idx="2">
+            <a:schemeClr val="accent1">
+              <a:shade val="15000"/>
+            </a:schemeClr>
+          </a:lnRef>
+          <a:fillRef idx="1">
+            <a:schemeClr val="accent1"/>
+          </a:fillRef>
+          <a:effectRef idx="0">
+            <a:schemeClr val="accent1"/>
+          </a:effectRef>
+          <a:fontRef idx="minor">
+            <a:schemeClr val="lt1"/>
+          </a:fontRef>
+        </p:style>
+        <p:txBody>
+          <a:bodyPr rtlCol="0" anchor="ctr"/>
+          <a:lstStyle/>
+          <a:p>
+            <a:pPr algn="ctr"/>
+            <a:r>
+              <a:rPr lang="en-US" sz="600" dirty="0">
+                <a:ln w="0"/>
+                <a:solidFill>
+                  <a:schemeClr val="bg1"/>
+                </a:solidFill>
+                <a:effectLst>
+                  <a:outerShdw blurRad="38100" dist="19050" dir="2700000" algn="tl" rotWithShape="0">
+                    <a:schemeClr val="dk1">
+                      <a:alpha val="40000"/>
+                    </a:schemeClr>
+                  </a:outerShdw>
+                </a:effectLst>
+              </a:rPr>
+              <a:t>Rec in 1</a:t>
+            </a:r>
+          </a:p>
+        </p:txBody>
+      </p:sp>
+      <p:sp>
+        <p:nvSpPr>
+          <p:cNvPr id="57" name="Rectangle 56">
+            <a:extLst>
+              <a:ext uri="{FF2B5EF4-FFF2-40B4-BE49-F238E27FC236}">
+                <a16:creationId xmlns:a16="http://schemas.microsoft.com/office/drawing/2014/main" id="{D7AA5639-0760-7E30-FBAE-0D2F67BC6806}"/>
+              </a:ext>
+            </a:extLst>
+          </p:cNvPr>
+          <p:cNvSpPr/>
+          <p:nvPr/>
+        </p:nvSpPr>
+        <p:spPr>
+          <a:xfrm>
+            <a:off x="9179809" y="3511636"/>
+            <a:ext cx="458632" cy="233310"/>
+          </a:xfrm>
+          <a:prstGeom prst="rect">
+            <a:avLst/>
+          </a:prstGeom>
+          <a:solidFill>
+            <a:srgbClr val="C00000"/>
+          </a:solidFill>
+          <a:ln>
+            <a:noFill/>
+          </a:ln>
+        </p:spPr>
+        <p:style>
+          <a:lnRef idx="2">
+            <a:schemeClr val="accent1">
+              <a:shade val="15000"/>
+            </a:schemeClr>
+          </a:lnRef>
+          <a:fillRef idx="1">
+            <a:schemeClr val="accent1"/>
+          </a:fillRef>
+          <a:effectRef idx="0">
+            <a:schemeClr val="accent1"/>
+          </a:effectRef>
+          <a:fontRef idx="minor">
+            <a:schemeClr val="lt1"/>
+          </a:fontRef>
+        </p:style>
+        <p:txBody>
+          <a:bodyPr rtlCol="0" anchor="ctr"/>
+          <a:lstStyle/>
+          <a:p>
+            <a:pPr algn="ctr"/>
+            <a:r>
+              <a:rPr lang="en-US" sz="600" dirty="0">
+                <a:ln w="0"/>
+                <a:solidFill>
+                  <a:schemeClr val="bg1"/>
+                </a:solidFill>
+                <a:effectLst>
+                  <a:outerShdw blurRad="38100" dist="19050" dir="2700000" algn="tl" rotWithShape="0">
+                    <a:schemeClr val="dk1">
+                      <a:alpha val="40000"/>
+                    </a:schemeClr>
+                  </a:outerShdw>
+                </a:effectLst>
+              </a:rPr>
+              <a:t>Rec in 2</a:t>
+            </a:r>
+          </a:p>
+        </p:txBody>
+      </p:sp>
+      <p:sp>
+        <p:nvSpPr>
+          <p:cNvPr id="58" name="TextBox 57">
+            <a:extLst>
+              <a:ext uri="{FF2B5EF4-FFF2-40B4-BE49-F238E27FC236}">
+                <a16:creationId xmlns:a16="http://schemas.microsoft.com/office/drawing/2014/main" id="{E1EE6D91-8270-2E24-1D3C-57C5E908B8EF}"/>
+              </a:ext>
+            </a:extLst>
+          </p:cNvPr>
+          <p:cNvSpPr txBox="1"/>
+          <p:nvPr/>
+        </p:nvSpPr>
+        <p:spPr>
+          <a:xfrm>
+            <a:off x="7666299" y="3885183"/>
+            <a:ext cx="881733" cy="553998"/>
+          </a:xfrm>
+          <a:prstGeom prst="rect">
+            <a:avLst/>
+          </a:prstGeom>
+          <a:noFill/>
+        </p:spPr>
+        <p:txBody>
+          <a:bodyPr wrap="square" rtlCol="0">
+            <a:spAutoFit/>
+          </a:bodyPr>
+          <a:lstStyle/>
+          <a:p>
+            <a:r>
+              <a:rPr lang="en-US" sz="1000" dirty="0">
+                <a:solidFill>
+                  <a:srgbClr val="7030A0"/>
+                </a:solidFill>
+              </a:rPr>
+              <a:t>Mod X/Y do not affect Turing</a:t>
             </a:r>
           </a:p>
         </p:txBody>

</xml_diff>